<commit_message>
methANNol powerpoint - current status
</commit_message>
<xml_diff>
--- a/methANNol.pptx
+++ b/methANNol.pptx
@@ -5,7 +5,7 @@
     <p:sldMasterId id="2147483648" r:id="rId1"/>
   </p:sldMasterIdLst>
   <p:notesMasterIdLst>
-    <p:notesMasterId r:id="rId11"/>
+    <p:notesMasterId r:id="rId13"/>
   </p:notesMasterIdLst>
   <p:sldIdLst>
     <p:sldId id="256" r:id="rId2"/>
@@ -14,9 +14,11 @@
     <p:sldId id="261" r:id="rId5"/>
     <p:sldId id="262" r:id="rId6"/>
     <p:sldId id="263" r:id="rId7"/>
-    <p:sldId id="264" r:id="rId8"/>
-    <p:sldId id="259" r:id="rId9"/>
-    <p:sldId id="258" r:id="rId10"/>
+    <p:sldId id="265" r:id="rId8"/>
+    <p:sldId id="267" r:id="rId9"/>
+    <p:sldId id="266" r:id="rId10"/>
+    <p:sldId id="264" r:id="rId11"/>
+    <p:sldId id="258" r:id="rId12"/>
   </p:sldIdLst>
   <p:sldSz cx="12192000" cy="6858000"/>
   <p:notesSz cx="6797675" cy="9856788"/>
@@ -216,7 +218,7 @@
           <a:p>
             <a:fld id="{CB22D906-12E9-42EA-8A02-A1A7582BC19D}" type="datetimeFigureOut">
               <a:rPr lang="de-DE" smtClean="0"/>
-              <a:t>01.04.25</a:t>
+              <a:t>02.04.25</a:t>
             </a:fld>
             <a:endParaRPr lang="de-DE"/>
           </a:p>
@@ -2863,6 +2865,1419 @@
 </p:sld>
 </file>
 
+<file path=ppt/slides/slide10.xml><?xml version="1.0" encoding="utf-8"?>
+<p:sld xmlns:a="http://schemas.openxmlformats.org/drawingml/2006/main" xmlns:r="http://schemas.openxmlformats.org/officeDocument/2006/relationships" xmlns:p="http://schemas.openxmlformats.org/presentationml/2006/main">
+  <p:cSld>
+    <p:spTree>
+      <p:nvGrpSpPr>
+        <p:cNvPr id="1" name=""/>
+        <p:cNvGrpSpPr/>
+        <p:nvPr/>
+      </p:nvGrpSpPr>
+      <p:grpSpPr>
+        <a:xfrm>
+          <a:off x="0" y="0"/>
+          <a:ext cx="0" cy="0"/>
+          <a:chOff x="0" y="0"/>
+          <a:chExt cx="0" cy="0"/>
+        </a:xfrm>
+      </p:grpSpPr>
+      <p:sp>
+        <p:nvSpPr>
+          <p:cNvPr id="2" name="Titel 1">
+            <a:extLst>
+              <a:ext uri="{FF2B5EF4-FFF2-40B4-BE49-F238E27FC236}">
+                <a16:creationId xmlns:a16="http://schemas.microsoft.com/office/drawing/2014/main" id="{6C03BE77-D8C4-AF59-A2BB-92C450017A80}"/>
+              </a:ext>
+            </a:extLst>
+          </p:cNvPr>
+          <p:cNvSpPr>
+            <a:spLocks noGrp="1"/>
+          </p:cNvSpPr>
+          <p:nvPr>
+            <p:ph type="title"/>
+          </p:nvPr>
+        </p:nvSpPr>
+        <p:spPr/>
+        <p:txBody>
+          <a:bodyPr/>
+          <a:lstStyle/>
+          <a:p>
+            <a:r>
+              <a:rPr lang="de-DE" dirty="0" err="1"/>
+              <a:t>Current</a:t>
+            </a:r>
+            <a:r>
+              <a:rPr lang="de-DE" dirty="0"/>
+              <a:t> </a:t>
+            </a:r>
+            <a:r>
+              <a:rPr lang="de-DE" dirty="0" err="1"/>
+              <a:t>challenges</a:t>
+            </a:r>
+            <a:r>
+              <a:rPr lang="de-DE" dirty="0"/>
+              <a:t>/</a:t>
+            </a:r>
+            <a:r>
+              <a:rPr lang="de-DE" dirty="0" err="1"/>
+              <a:t>problems</a:t>
+            </a:r>
+            <a:endParaRPr lang="de-DE" dirty="0"/>
+          </a:p>
+        </p:txBody>
+      </p:sp>
+      <p:sp>
+        <p:nvSpPr>
+          <p:cNvPr id="3" name="Inhaltsplatzhalter 2">
+            <a:extLst>
+              <a:ext uri="{FF2B5EF4-FFF2-40B4-BE49-F238E27FC236}">
+                <a16:creationId xmlns:a16="http://schemas.microsoft.com/office/drawing/2014/main" id="{7A5CE63F-4466-613C-4CD1-D0677109B7AF}"/>
+              </a:ext>
+            </a:extLst>
+          </p:cNvPr>
+          <p:cNvSpPr>
+            <a:spLocks noGrp="1"/>
+          </p:cNvSpPr>
+          <p:nvPr>
+            <p:ph idx="1"/>
+          </p:nvPr>
+        </p:nvSpPr>
+        <p:spPr/>
+        <p:txBody>
+          <a:bodyPr/>
+          <a:lstStyle/>
+          <a:p>
+            <a:pPr marL="457200" indent="-457200">
+              <a:buFont typeface="+mj-lt"/>
+              <a:buAutoNum type="arabicPeriod"/>
+            </a:pPr>
+            <a:r>
+              <a:rPr lang="de-DE" dirty="0"/>
+              <a:t>Computational time: </a:t>
+            </a:r>
+            <a:r>
+              <a:rPr lang="de-DE" dirty="0" err="1"/>
+              <a:t>if</a:t>
+            </a:r>
+            <a:r>
+              <a:rPr lang="de-DE" dirty="0"/>
+              <a:t> </a:t>
+            </a:r>
+            <a:r>
+              <a:rPr lang="de-DE" dirty="0" err="1"/>
+              <a:t>more</a:t>
+            </a:r>
+            <a:r>
+              <a:rPr lang="de-DE" dirty="0"/>
+              <a:t> robust </a:t>
+            </a:r>
+            <a:r>
+              <a:rPr lang="de-DE" dirty="0" err="1"/>
+              <a:t>solvers</a:t>
+            </a:r>
+            <a:r>
+              <a:rPr lang="de-DE" dirty="0"/>
+              <a:t> like </a:t>
+            </a:r>
+            <a:r>
+              <a:rPr lang="de-DE" dirty="0" err="1"/>
+              <a:t>basinhopping</a:t>
+            </a:r>
+            <a:r>
+              <a:rPr lang="de-DE" dirty="0"/>
+              <a:t> </a:t>
+            </a:r>
+            <a:r>
+              <a:rPr lang="de-DE" dirty="0" err="1"/>
+              <a:t>are</a:t>
+            </a:r>
+            <a:r>
+              <a:rPr lang="de-DE" dirty="0"/>
+              <a:t> </a:t>
+            </a:r>
+            <a:r>
+              <a:rPr lang="de-DE" dirty="0" err="1"/>
+              <a:t>used</a:t>
+            </a:r>
+            <a:r>
+              <a:rPr lang="de-DE" dirty="0"/>
+              <a:t>, </a:t>
+            </a:r>
+            <a:r>
+              <a:rPr lang="de-DE" dirty="0" err="1"/>
+              <a:t>no</a:t>
+            </a:r>
+            <a:r>
+              <a:rPr lang="de-DE" dirty="0"/>
+              <a:t> </a:t>
+            </a:r>
+            <a:r>
+              <a:rPr lang="de-DE" dirty="0" err="1"/>
+              <a:t>jumps</a:t>
+            </a:r>
+            <a:r>
+              <a:rPr lang="de-DE" dirty="0"/>
+              <a:t> in </a:t>
+            </a:r>
+            <a:r>
+              <a:rPr lang="de-DE" dirty="0" err="1"/>
+              <a:t>plots</a:t>
+            </a:r>
+            <a:r>
+              <a:rPr lang="de-DE" dirty="0"/>
+              <a:t> in </a:t>
+            </a:r>
+            <a:r>
+              <a:rPr lang="de-DE" dirty="0" err="1"/>
+              <a:t>comparison</a:t>
+            </a:r>
+            <a:r>
+              <a:rPr lang="de-DE" dirty="0"/>
+              <a:t> </a:t>
+            </a:r>
+            <a:r>
+              <a:rPr lang="de-DE" dirty="0" err="1"/>
+              <a:t>to</a:t>
+            </a:r>
+            <a:r>
+              <a:rPr lang="de-DE" dirty="0"/>
+              <a:t> </a:t>
+            </a:r>
+            <a:r>
+              <a:rPr lang="de-DE" dirty="0" err="1"/>
+              <a:t>literature</a:t>
+            </a:r>
+            <a:r>
+              <a:rPr lang="de-DE" dirty="0"/>
+              <a:t> </a:t>
+            </a:r>
+            <a:r>
+              <a:rPr lang="de-DE" dirty="0" err="1"/>
+              <a:t>data</a:t>
+            </a:r>
+            <a:r>
+              <a:rPr lang="de-DE" dirty="0"/>
+              <a:t> </a:t>
+            </a:r>
+            <a:r>
+              <a:rPr lang="de-DE" dirty="0" err="1"/>
+              <a:t>were</a:t>
+            </a:r>
+            <a:r>
+              <a:rPr lang="de-DE" dirty="0"/>
+              <a:t> </a:t>
+            </a:r>
+            <a:r>
+              <a:rPr lang="de-DE" dirty="0" err="1"/>
+              <a:t>observed</a:t>
+            </a:r>
+            <a:r>
+              <a:rPr lang="de-DE" dirty="0"/>
+              <a:t>, </a:t>
+            </a:r>
+            <a:r>
+              <a:rPr lang="de-DE" dirty="0" err="1"/>
+              <a:t>see</a:t>
+            </a:r>
+            <a:r>
+              <a:rPr lang="de-DE" dirty="0"/>
+              <a:t> PowerPoint </a:t>
+            </a:r>
+            <a:r>
+              <a:rPr lang="de-DE" dirty="0" err="1"/>
+              <a:t>figures</a:t>
+            </a:r>
+            <a:r>
+              <a:rPr lang="de-DE" dirty="0"/>
+              <a:t> and </a:t>
+            </a:r>
+            <a:r>
+              <a:rPr lang="de-DE" dirty="0" err="1"/>
+              <a:t>git</a:t>
+            </a:r>
+            <a:r>
+              <a:rPr lang="de-DE" dirty="0"/>
+              <a:t> </a:t>
+            </a:r>
+            <a:r>
+              <a:rPr lang="de-DE" dirty="0" err="1"/>
+              <a:t>repo</a:t>
+            </a:r>
+            <a:endParaRPr lang="de-DE" dirty="0"/>
+          </a:p>
+          <a:p>
+            <a:pPr lvl="1"/>
+            <a:r>
+              <a:rPr lang="de-DE" dirty="0"/>
+              <a:t>BUT: </a:t>
+            </a:r>
+            <a:r>
+              <a:rPr lang="de-DE" dirty="0" err="1"/>
+              <a:t>way</a:t>
+            </a:r>
+            <a:r>
+              <a:rPr lang="de-DE" dirty="0"/>
+              <a:t> </a:t>
+            </a:r>
+            <a:r>
+              <a:rPr lang="de-DE" dirty="0" err="1"/>
+              <a:t>too</a:t>
+            </a:r>
+            <a:r>
+              <a:rPr lang="de-DE" dirty="0"/>
+              <a:t> time </a:t>
+            </a:r>
+            <a:r>
+              <a:rPr lang="de-DE" dirty="0" err="1"/>
+              <a:t>consuming</a:t>
+            </a:r>
+            <a:r>
+              <a:rPr lang="de-DE" dirty="0"/>
+              <a:t>, </a:t>
+            </a:r>
+            <a:r>
+              <a:rPr lang="de-DE" dirty="0" err="1"/>
+              <a:t>if</a:t>
+            </a:r>
+            <a:r>
+              <a:rPr lang="de-DE" dirty="0"/>
+              <a:t> </a:t>
+            </a:r>
+            <a:r>
+              <a:rPr lang="de-DE" dirty="0" err="1"/>
+              <a:t>f.e</a:t>
+            </a:r>
+            <a:r>
+              <a:rPr lang="de-DE" dirty="0"/>
+              <a:t>. 1e6 </a:t>
+            </a:r>
+            <a:r>
+              <a:rPr lang="de-DE" dirty="0" err="1"/>
+              <a:t>training</a:t>
+            </a:r>
+            <a:r>
+              <a:rPr lang="de-DE" dirty="0"/>
+              <a:t> </a:t>
+            </a:r>
+            <a:r>
+              <a:rPr lang="de-DE" dirty="0" err="1"/>
+              <a:t>data</a:t>
+            </a:r>
+            <a:r>
+              <a:rPr lang="de-DE" dirty="0"/>
+              <a:t> </a:t>
+            </a:r>
+            <a:r>
+              <a:rPr lang="de-DE" dirty="0" err="1"/>
+              <a:t>points</a:t>
+            </a:r>
+            <a:r>
+              <a:rPr lang="de-DE" dirty="0"/>
+              <a:t> </a:t>
+            </a:r>
+            <a:r>
+              <a:rPr lang="de-DE" dirty="0" err="1"/>
+              <a:t>should</a:t>
+            </a:r>
+            <a:r>
+              <a:rPr lang="de-DE" dirty="0"/>
+              <a:t> </a:t>
+            </a:r>
+            <a:r>
+              <a:rPr lang="de-DE" dirty="0" err="1"/>
+              <a:t>be</a:t>
+            </a:r>
+            <a:r>
+              <a:rPr lang="de-DE" dirty="0"/>
+              <a:t> </a:t>
+            </a:r>
+            <a:r>
+              <a:rPr lang="de-DE" dirty="0" err="1"/>
+              <a:t>generated</a:t>
+            </a:r>
+            <a:r>
+              <a:rPr lang="de-DE" dirty="0"/>
+              <a:t> (</a:t>
+            </a:r>
+            <a:r>
+              <a:rPr lang="de-DE" dirty="0" err="1"/>
+              <a:t>would</a:t>
+            </a:r>
+            <a:r>
+              <a:rPr lang="de-DE" dirty="0"/>
+              <a:t> </a:t>
+            </a:r>
+            <a:r>
+              <a:rPr lang="de-DE" dirty="0" err="1"/>
+              <a:t>take</a:t>
+            </a:r>
+            <a:r>
+              <a:rPr lang="de-DE" dirty="0"/>
+              <a:t> </a:t>
+            </a:r>
+            <a:r>
+              <a:rPr lang="de-DE" dirty="0" err="1"/>
+              <a:t>more</a:t>
+            </a:r>
+            <a:r>
+              <a:rPr lang="de-DE" dirty="0"/>
+              <a:t> </a:t>
+            </a:r>
+            <a:r>
+              <a:rPr lang="de-DE" dirty="0" err="1"/>
+              <a:t>than</a:t>
+            </a:r>
+            <a:r>
+              <a:rPr lang="de-DE" dirty="0"/>
+              <a:t> </a:t>
+            </a:r>
+            <a:r>
+              <a:rPr lang="de-DE" dirty="0" err="1"/>
+              <a:t>one</a:t>
+            </a:r>
+            <a:r>
+              <a:rPr lang="de-DE" dirty="0"/>
+              <a:t> </a:t>
+            </a:r>
+            <a:r>
+              <a:rPr lang="de-DE" dirty="0" err="1"/>
+              <a:t>week</a:t>
+            </a:r>
+            <a:r>
+              <a:rPr lang="de-DE" dirty="0"/>
+              <a:t> </a:t>
+            </a:r>
+            <a:r>
+              <a:rPr lang="de-DE" dirty="0" err="1"/>
+              <a:t>computational</a:t>
+            </a:r>
+            <a:r>
+              <a:rPr lang="de-DE" dirty="0"/>
+              <a:t> time on </a:t>
+            </a:r>
+            <a:r>
+              <a:rPr lang="de-DE" dirty="0" err="1"/>
+              <a:t>my</a:t>
+            </a:r>
+            <a:r>
+              <a:rPr lang="de-DE" dirty="0"/>
+              <a:t> </a:t>
+            </a:r>
+            <a:r>
+              <a:rPr lang="de-DE" dirty="0" err="1"/>
+              <a:t>laptop</a:t>
+            </a:r>
+            <a:r>
+              <a:rPr lang="de-DE" dirty="0"/>
+              <a:t>…..)</a:t>
+            </a:r>
+          </a:p>
+          <a:p>
+            <a:pPr marL="457200" indent="-457200">
+              <a:buFont typeface="+mj-lt"/>
+              <a:buAutoNum type="arabicPeriod"/>
+            </a:pPr>
+            <a:r>
+              <a:rPr lang="de-DE" dirty="0"/>
+              <a:t>GEM </a:t>
+            </a:r>
+            <a:r>
+              <a:rPr lang="de-DE" dirty="0" err="1"/>
+              <a:t>with</a:t>
+            </a:r>
+            <a:r>
+              <a:rPr lang="de-DE" dirty="0"/>
+              <a:t> SLSQP (</a:t>
+            </a:r>
+            <a:r>
+              <a:rPr lang="de-DE" dirty="0" err="1"/>
+              <a:t>faster</a:t>
+            </a:r>
+            <a:r>
+              <a:rPr lang="de-DE" dirty="0"/>
+              <a:t> </a:t>
+            </a:r>
+            <a:r>
+              <a:rPr lang="de-DE" dirty="0" err="1"/>
+              <a:t>calculation</a:t>
+            </a:r>
+            <a:r>
+              <a:rPr lang="de-DE" dirty="0"/>
+              <a:t>):</a:t>
+            </a:r>
+          </a:p>
+          <a:p>
+            <a:pPr lvl="1"/>
+            <a:r>
+              <a:rPr lang="de-DE" dirty="0"/>
+              <a:t>Same </a:t>
+            </a:r>
+            <a:r>
+              <a:rPr lang="de-DE" dirty="0" err="1"/>
+              <a:t>problem</a:t>
+            </a:r>
+            <a:r>
+              <a:rPr lang="de-DE" dirty="0"/>
+              <a:t> </a:t>
+            </a:r>
+            <a:r>
+              <a:rPr lang="de-DE" dirty="0" err="1"/>
+              <a:t>as</a:t>
+            </a:r>
+            <a:r>
+              <a:rPr lang="de-DE" dirty="0"/>
+              <a:t> </a:t>
+            </a:r>
+            <a:r>
+              <a:rPr lang="de-DE" dirty="0" err="1"/>
+              <a:t>with</a:t>
+            </a:r>
+            <a:r>
+              <a:rPr lang="de-DE" dirty="0"/>
+              <a:t> </a:t>
+            </a:r>
+            <a:r>
+              <a:rPr lang="de-DE" dirty="0" err="1"/>
+              <a:t>methANNation</a:t>
+            </a:r>
+            <a:r>
+              <a:rPr lang="de-DE" dirty="0"/>
+              <a:t>: </a:t>
+            </a:r>
+            <a:r>
+              <a:rPr lang="de-DE" dirty="0" err="1"/>
+              <a:t>obviously</a:t>
+            </a:r>
+            <a:r>
+              <a:rPr lang="de-DE" dirty="0"/>
+              <a:t> </a:t>
+            </a:r>
+            <a:r>
+              <a:rPr lang="de-DE" dirty="0" err="1"/>
+              <a:t>wrong</a:t>
+            </a:r>
+            <a:r>
+              <a:rPr lang="de-DE" dirty="0"/>
+              <a:t> </a:t>
+            </a:r>
+            <a:r>
+              <a:rPr lang="de-DE" dirty="0" err="1"/>
+              <a:t>solution</a:t>
+            </a:r>
+            <a:r>
+              <a:rPr lang="de-DE" dirty="0"/>
+              <a:t> </a:t>
+            </a:r>
+            <a:r>
+              <a:rPr lang="de-DE" dirty="0" err="1"/>
+              <a:t>found</a:t>
+            </a:r>
+            <a:r>
+              <a:rPr lang="de-DE" dirty="0"/>
+              <a:t> </a:t>
+            </a:r>
+            <a:r>
+              <a:rPr lang="de-DE" dirty="0" err="1"/>
+              <a:t>even</a:t>
+            </a:r>
+            <a:r>
+              <a:rPr lang="de-DE" dirty="0"/>
+              <a:t> </a:t>
+            </a:r>
+            <a:r>
+              <a:rPr lang="de-DE" dirty="0" err="1"/>
+              <a:t>though</a:t>
+            </a:r>
+            <a:r>
+              <a:rPr lang="de-DE" dirty="0"/>
+              <a:t> </a:t>
+            </a:r>
+            <a:r>
+              <a:rPr lang="de-DE" dirty="0" err="1"/>
+              <a:t>solver</a:t>
+            </a:r>
+            <a:r>
+              <a:rPr lang="de-DE" dirty="0"/>
+              <a:t> </a:t>
+            </a:r>
+            <a:r>
+              <a:rPr lang="de-DE" dirty="0" err="1"/>
+              <a:t>converged</a:t>
+            </a:r>
+            <a:r>
+              <a:rPr lang="de-DE" dirty="0"/>
+              <a:t> </a:t>
+            </a:r>
+            <a:r>
+              <a:rPr lang="de-DE" dirty="0">
+                <a:sym typeface="Wingdings" pitchFamily="2" charset="2"/>
+              </a:rPr>
+              <a:t> extra </a:t>
+            </a:r>
+            <a:r>
+              <a:rPr lang="de-DE" dirty="0" err="1">
+                <a:sym typeface="Wingdings" pitchFamily="2" charset="2"/>
+              </a:rPr>
+              <a:t>criterion</a:t>
+            </a:r>
+            <a:r>
+              <a:rPr lang="de-DE" dirty="0">
+                <a:sym typeface="Wingdings" pitchFamily="2" charset="2"/>
+              </a:rPr>
+              <a:t> </a:t>
+            </a:r>
+            <a:r>
+              <a:rPr lang="de-DE" dirty="0" err="1">
+                <a:sym typeface="Wingdings" pitchFamily="2" charset="2"/>
+              </a:rPr>
+              <a:t>needed</a:t>
+            </a:r>
+            <a:r>
+              <a:rPr lang="de-DE" dirty="0">
+                <a:sym typeface="Wingdings" pitchFamily="2" charset="2"/>
+              </a:rPr>
+              <a:t> </a:t>
+            </a:r>
+            <a:r>
+              <a:rPr lang="de-DE" dirty="0" err="1">
+                <a:sym typeface="Wingdings" pitchFamily="2" charset="2"/>
+              </a:rPr>
+              <a:t>to</a:t>
+            </a:r>
+            <a:r>
+              <a:rPr lang="de-DE" dirty="0">
+                <a:sym typeface="Wingdings" pitchFamily="2" charset="2"/>
+              </a:rPr>
+              <a:t> </a:t>
+            </a:r>
+            <a:r>
+              <a:rPr lang="de-DE" dirty="0" err="1">
+                <a:sym typeface="Wingdings" pitchFamily="2" charset="2"/>
+              </a:rPr>
+              <a:t>evaluate</a:t>
+            </a:r>
+            <a:r>
+              <a:rPr lang="de-DE" dirty="0">
+                <a:sym typeface="Wingdings" pitchFamily="2" charset="2"/>
+              </a:rPr>
+              <a:t> </a:t>
+            </a:r>
+            <a:r>
+              <a:rPr lang="de-DE" dirty="0" err="1">
+                <a:sym typeface="Wingdings" pitchFamily="2" charset="2"/>
+              </a:rPr>
+              <a:t>convergence</a:t>
+            </a:r>
+            <a:endParaRPr lang="de-DE" dirty="0">
+              <a:sym typeface="Wingdings" pitchFamily="2" charset="2"/>
+            </a:endParaRPr>
+          </a:p>
+          <a:p>
+            <a:pPr lvl="1"/>
+            <a:r>
+              <a:rPr lang="de-DE" dirty="0">
+                <a:sym typeface="Wingdings" pitchFamily="2" charset="2"/>
+              </a:rPr>
+              <a:t>Problem: additional </a:t>
+            </a:r>
+            <a:r>
+              <a:rPr lang="de-DE" dirty="0" err="1">
+                <a:sym typeface="Wingdings" pitchFamily="2" charset="2"/>
+              </a:rPr>
+              <a:t>two</a:t>
+            </a:r>
+            <a:r>
+              <a:rPr lang="de-DE" dirty="0">
+                <a:sym typeface="Wingdings" pitchFamily="2" charset="2"/>
+              </a:rPr>
+              <a:t> </a:t>
+            </a:r>
+            <a:r>
+              <a:rPr lang="de-DE" dirty="0" err="1">
+                <a:sym typeface="Wingdings" pitchFamily="2" charset="2"/>
+              </a:rPr>
+              <a:t>phase</a:t>
+            </a:r>
+            <a:r>
+              <a:rPr lang="de-DE" dirty="0">
+                <a:sym typeface="Wingdings" pitchFamily="2" charset="2"/>
+              </a:rPr>
+              <a:t> </a:t>
+            </a:r>
+            <a:r>
+              <a:rPr lang="de-DE" dirty="0" err="1">
+                <a:sym typeface="Wingdings" pitchFamily="2" charset="2"/>
+              </a:rPr>
+              <a:t>region</a:t>
+            </a:r>
+            <a:r>
+              <a:rPr lang="de-DE" dirty="0">
+                <a:sym typeface="Wingdings" pitchFamily="2" charset="2"/>
+              </a:rPr>
+              <a:t>  </a:t>
+            </a:r>
+            <a:r>
+              <a:rPr lang="de-DE" dirty="0" err="1">
+                <a:sym typeface="Wingdings" pitchFamily="2" charset="2"/>
+              </a:rPr>
+              <a:t>what</a:t>
+            </a:r>
+            <a:r>
+              <a:rPr lang="de-DE" dirty="0">
+                <a:sym typeface="Wingdings" pitchFamily="2" charset="2"/>
+              </a:rPr>
+              <a:t> </a:t>
+            </a:r>
+            <a:r>
+              <a:rPr lang="de-DE" dirty="0" err="1">
+                <a:sym typeface="Wingdings" pitchFamily="2" charset="2"/>
+              </a:rPr>
+              <a:t>to</a:t>
+            </a:r>
+            <a:r>
+              <a:rPr lang="de-DE" dirty="0">
+                <a:sym typeface="Wingdings" pitchFamily="2" charset="2"/>
+              </a:rPr>
+              <a:t> do…?</a:t>
+            </a:r>
+          </a:p>
+          <a:p>
+            <a:pPr lvl="1"/>
+            <a:r>
+              <a:rPr lang="de-DE" dirty="0" err="1">
+                <a:sym typeface="Wingdings" pitchFamily="2" charset="2"/>
+              </a:rPr>
+              <a:t>For</a:t>
+            </a:r>
+            <a:r>
+              <a:rPr lang="de-DE" dirty="0">
+                <a:sym typeface="Wingdings" pitchFamily="2" charset="2"/>
+              </a:rPr>
+              <a:t> high </a:t>
+            </a:r>
+            <a:r>
+              <a:rPr lang="de-DE" dirty="0" err="1">
+                <a:sym typeface="Wingdings" pitchFamily="2" charset="2"/>
+              </a:rPr>
+              <a:t>temperatures</a:t>
+            </a:r>
+            <a:r>
+              <a:rPr lang="de-DE" dirty="0">
+                <a:sym typeface="Wingdings" pitchFamily="2" charset="2"/>
+              </a:rPr>
+              <a:t> </a:t>
+            </a:r>
+            <a:r>
+              <a:rPr lang="de-DE" dirty="0" err="1">
+                <a:sym typeface="Wingdings" pitchFamily="2" charset="2"/>
+              </a:rPr>
+              <a:t>however</a:t>
+            </a:r>
+            <a:r>
+              <a:rPr lang="de-DE" dirty="0">
+                <a:sym typeface="Wingdings" pitchFamily="2" charset="2"/>
+              </a:rPr>
+              <a:t>, K</a:t>
+            </a:r>
+            <a:r>
+              <a:rPr lang="de-DE" baseline="30000" dirty="0">
+                <a:sym typeface="Wingdings" pitchFamily="2" charset="2"/>
+              </a:rPr>
+              <a:t>0</a:t>
+            </a:r>
+            <a:r>
+              <a:rPr lang="de-DE" dirty="0">
+                <a:sym typeface="Wingdings" pitchFamily="2" charset="2"/>
+              </a:rPr>
+              <a:t> </a:t>
+            </a:r>
+            <a:r>
+              <a:rPr lang="de-DE" dirty="0" err="1">
+                <a:sym typeface="Wingdings" pitchFamily="2" charset="2"/>
+              </a:rPr>
+              <a:t>comparison</a:t>
+            </a:r>
+            <a:r>
+              <a:rPr lang="de-DE" dirty="0">
+                <a:sym typeface="Wingdings" pitchFamily="2" charset="2"/>
+              </a:rPr>
+              <a:t> </a:t>
+            </a:r>
+            <a:r>
+              <a:rPr lang="de-DE" dirty="0" err="1">
+                <a:sym typeface="Wingdings" pitchFamily="2" charset="2"/>
+              </a:rPr>
+              <a:t>would</a:t>
+            </a:r>
+            <a:r>
+              <a:rPr lang="de-DE" dirty="0">
+                <a:sym typeface="Wingdings" pitchFamily="2" charset="2"/>
+              </a:rPr>
+              <a:t> </a:t>
+            </a:r>
+            <a:r>
+              <a:rPr lang="de-DE" dirty="0" err="1">
+                <a:sym typeface="Wingdings" pitchFamily="2" charset="2"/>
+              </a:rPr>
+              <a:t>work</a:t>
+            </a:r>
+            <a:r>
+              <a:rPr lang="de-DE" dirty="0">
+                <a:sym typeface="Wingdings" pitchFamily="2" charset="2"/>
+              </a:rPr>
+              <a:t> </a:t>
+            </a:r>
+            <a:r>
+              <a:rPr lang="de-DE" dirty="0" err="1">
+                <a:sym typeface="Wingdings" pitchFamily="2" charset="2"/>
+              </a:rPr>
+              <a:t>very</a:t>
+            </a:r>
+            <a:r>
+              <a:rPr lang="de-DE" dirty="0">
+                <a:sym typeface="Wingdings" pitchFamily="2" charset="2"/>
+              </a:rPr>
+              <a:t> </a:t>
+            </a:r>
+            <a:r>
+              <a:rPr lang="de-DE" dirty="0" err="1">
+                <a:sym typeface="Wingdings" pitchFamily="2" charset="2"/>
+              </a:rPr>
+              <a:t>good</a:t>
+            </a:r>
+            <a:endParaRPr lang="de-DE" dirty="0">
+              <a:sym typeface="Wingdings" pitchFamily="2" charset="2"/>
+            </a:endParaRPr>
+          </a:p>
+          <a:p>
+            <a:pPr lvl="1"/>
+            <a:r>
+              <a:rPr lang="de-DE" dirty="0" err="1">
+                <a:sym typeface="Wingdings" pitchFamily="2" charset="2"/>
+              </a:rPr>
+              <a:t>Nevertheless</a:t>
+            </a:r>
+            <a:r>
+              <a:rPr lang="de-DE" dirty="0">
+                <a:sym typeface="Wingdings" pitchFamily="2" charset="2"/>
+              </a:rPr>
+              <a:t>: </a:t>
+            </a:r>
+            <a:r>
+              <a:rPr lang="de-DE" dirty="0" err="1">
+                <a:sym typeface="Wingdings" pitchFamily="2" charset="2"/>
+              </a:rPr>
+              <a:t>problematic</a:t>
+            </a:r>
+            <a:r>
+              <a:rPr lang="de-DE" dirty="0">
+                <a:sym typeface="Wingdings" pitchFamily="2" charset="2"/>
+              </a:rPr>
+              <a:t> </a:t>
+            </a:r>
+            <a:r>
+              <a:rPr lang="de-DE" dirty="0" err="1">
+                <a:sym typeface="Wingdings" pitchFamily="2" charset="2"/>
+              </a:rPr>
+              <a:t>as</a:t>
+            </a:r>
+            <a:r>
+              <a:rPr lang="de-DE" dirty="0">
+                <a:sym typeface="Wingdings" pitchFamily="2" charset="2"/>
+              </a:rPr>
+              <a:t> </a:t>
+            </a:r>
+            <a:r>
+              <a:rPr lang="de-DE" dirty="0" err="1">
+                <a:sym typeface="Wingdings" pitchFamily="2" charset="2"/>
+              </a:rPr>
+              <a:t>one</a:t>
+            </a:r>
+            <a:r>
+              <a:rPr lang="de-DE" dirty="0">
+                <a:sym typeface="Wingdings" pitchFamily="2" charset="2"/>
+              </a:rPr>
+              <a:t> </a:t>
+            </a:r>
+            <a:r>
+              <a:rPr lang="de-DE" dirty="0" err="1">
+                <a:sym typeface="Wingdings" pitchFamily="2" charset="2"/>
+              </a:rPr>
+              <a:t>can</a:t>
+            </a:r>
+            <a:r>
+              <a:rPr lang="de-DE" dirty="0">
+                <a:sym typeface="Wingdings" pitchFamily="2" charset="2"/>
+              </a:rPr>
+              <a:t> </a:t>
+            </a:r>
+            <a:r>
+              <a:rPr lang="de-DE" dirty="0" err="1">
+                <a:sym typeface="Wingdings" pitchFamily="2" charset="2"/>
+              </a:rPr>
+              <a:t>never</a:t>
+            </a:r>
+            <a:r>
+              <a:rPr lang="de-DE" dirty="0">
+                <a:sym typeface="Wingdings" pitchFamily="2" charset="2"/>
+              </a:rPr>
+              <a:t> </a:t>
+            </a:r>
+            <a:r>
+              <a:rPr lang="de-DE" dirty="0" err="1">
+                <a:sym typeface="Wingdings" pitchFamily="2" charset="2"/>
+              </a:rPr>
+              <a:t>be</a:t>
+            </a:r>
+            <a:r>
+              <a:rPr lang="de-DE" dirty="0">
+                <a:sym typeface="Wingdings" pitchFamily="2" charset="2"/>
+              </a:rPr>
+              <a:t> 100% </a:t>
+            </a:r>
+            <a:r>
+              <a:rPr lang="de-DE" dirty="0" err="1">
+                <a:sym typeface="Wingdings" pitchFamily="2" charset="2"/>
+              </a:rPr>
+              <a:t>sure</a:t>
+            </a:r>
+            <a:r>
+              <a:rPr lang="de-DE" dirty="0">
+                <a:sym typeface="Wingdings" pitchFamily="2" charset="2"/>
+              </a:rPr>
+              <a:t> </a:t>
+            </a:r>
+            <a:r>
+              <a:rPr lang="de-DE" dirty="0" err="1">
+                <a:sym typeface="Wingdings" pitchFamily="2" charset="2"/>
+              </a:rPr>
+              <a:t>whether</a:t>
+            </a:r>
+            <a:r>
+              <a:rPr lang="de-DE" dirty="0">
+                <a:sym typeface="Wingdings" pitchFamily="2" charset="2"/>
+              </a:rPr>
+              <a:t> </a:t>
+            </a:r>
+            <a:r>
+              <a:rPr lang="de-DE" dirty="0" err="1">
+                <a:sym typeface="Wingdings" pitchFamily="2" charset="2"/>
+              </a:rPr>
+              <a:t>solution</a:t>
+            </a:r>
+            <a:r>
+              <a:rPr lang="de-DE" dirty="0">
+                <a:sym typeface="Wingdings" pitchFamily="2" charset="2"/>
+              </a:rPr>
+              <a:t> </a:t>
+            </a:r>
+            <a:r>
+              <a:rPr lang="de-DE" dirty="0" err="1">
+                <a:sym typeface="Wingdings" pitchFamily="2" charset="2"/>
+              </a:rPr>
+              <a:t>is</a:t>
+            </a:r>
+            <a:r>
+              <a:rPr lang="de-DE" dirty="0">
+                <a:sym typeface="Wingdings" pitchFamily="2" charset="2"/>
+              </a:rPr>
+              <a:t> </a:t>
+            </a:r>
+            <a:r>
+              <a:rPr lang="de-DE" dirty="0" err="1">
+                <a:sym typeface="Wingdings" pitchFamily="2" charset="2"/>
+              </a:rPr>
+              <a:t>correct</a:t>
+            </a:r>
+            <a:r>
+              <a:rPr lang="de-DE" dirty="0">
+                <a:sym typeface="Wingdings" pitchFamily="2" charset="2"/>
+              </a:rPr>
+              <a:t> </a:t>
+            </a:r>
+            <a:r>
+              <a:rPr lang="de-DE" dirty="0" err="1">
+                <a:sym typeface="Wingdings" pitchFamily="2" charset="2"/>
+              </a:rPr>
+              <a:t>or</a:t>
+            </a:r>
+            <a:r>
+              <a:rPr lang="de-DE" dirty="0">
+                <a:sym typeface="Wingdings" pitchFamily="2" charset="2"/>
+              </a:rPr>
+              <a:t> not</a:t>
+            </a:r>
+          </a:p>
+          <a:p>
+            <a:pPr marL="457200" indent="-457200">
+              <a:buFont typeface="+mj-lt"/>
+              <a:buAutoNum type="arabicPeriod"/>
+            </a:pPr>
+            <a:r>
+              <a:rPr lang="de-DE" dirty="0" err="1">
+                <a:sym typeface="Wingdings" pitchFamily="2" charset="2"/>
+              </a:rPr>
+              <a:t>Another</a:t>
+            </a:r>
+            <a:r>
+              <a:rPr lang="de-DE" dirty="0">
+                <a:sym typeface="Wingdings" pitchFamily="2" charset="2"/>
+              </a:rPr>
+              <a:t> </a:t>
+            </a:r>
+            <a:r>
+              <a:rPr lang="de-DE" dirty="0" err="1">
+                <a:sym typeface="Wingdings" pitchFamily="2" charset="2"/>
+              </a:rPr>
+              <a:t>problem</a:t>
+            </a:r>
+            <a:r>
+              <a:rPr lang="de-DE" dirty="0">
+                <a:sym typeface="Wingdings" pitchFamily="2" charset="2"/>
+              </a:rPr>
+              <a:t>:</a:t>
+            </a:r>
+          </a:p>
+          <a:p>
+            <a:pPr lvl="1"/>
+            <a:r>
+              <a:rPr lang="de-DE" dirty="0">
+                <a:sym typeface="Wingdings" pitchFamily="2" charset="2"/>
+              </a:rPr>
+              <a:t>A </a:t>
+            </a:r>
+            <a:r>
+              <a:rPr lang="de-DE" dirty="0" err="1">
+                <a:sym typeface="Wingdings" pitchFamily="2" charset="2"/>
+              </a:rPr>
+              <a:t>criterion</a:t>
+            </a:r>
+            <a:r>
+              <a:rPr lang="de-DE" dirty="0">
+                <a:sym typeface="Wingdings" pitchFamily="2" charset="2"/>
+              </a:rPr>
+              <a:t> </a:t>
+            </a:r>
+            <a:r>
+              <a:rPr lang="de-DE" dirty="0" err="1">
+                <a:sym typeface="Wingdings" pitchFamily="2" charset="2"/>
+              </a:rPr>
+              <a:t>to</a:t>
+            </a:r>
+            <a:r>
+              <a:rPr lang="de-DE" dirty="0">
+                <a:sym typeface="Wingdings" pitchFamily="2" charset="2"/>
+              </a:rPr>
+              <a:t> </a:t>
+            </a:r>
+            <a:r>
+              <a:rPr lang="de-DE" dirty="0" err="1">
+                <a:sym typeface="Wingdings" pitchFamily="2" charset="2"/>
+              </a:rPr>
+              <a:t>determine</a:t>
+            </a:r>
+            <a:r>
+              <a:rPr lang="de-DE" dirty="0">
+                <a:sym typeface="Wingdings" pitchFamily="2" charset="2"/>
+              </a:rPr>
+              <a:t> </a:t>
+            </a:r>
+            <a:r>
+              <a:rPr lang="de-DE" dirty="0" err="1">
+                <a:sym typeface="Wingdings" pitchFamily="2" charset="2"/>
+              </a:rPr>
+              <a:t>confidently</a:t>
+            </a:r>
+            <a:r>
+              <a:rPr lang="de-DE" dirty="0">
+                <a:sym typeface="Wingdings" pitchFamily="2" charset="2"/>
+              </a:rPr>
+              <a:t> </a:t>
+            </a:r>
+            <a:r>
+              <a:rPr lang="de-DE" dirty="0" err="1">
+                <a:sym typeface="Wingdings" pitchFamily="2" charset="2"/>
+              </a:rPr>
+              <a:t>whether</a:t>
+            </a:r>
+            <a:r>
+              <a:rPr lang="de-DE" dirty="0">
+                <a:sym typeface="Wingdings" pitchFamily="2" charset="2"/>
+              </a:rPr>
+              <a:t> </a:t>
+            </a:r>
+            <a:r>
+              <a:rPr lang="de-DE" dirty="0" err="1">
+                <a:sym typeface="Wingdings" pitchFamily="2" charset="2"/>
+              </a:rPr>
+              <a:t>the</a:t>
+            </a:r>
+            <a:r>
+              <a:rPr lang="de-DE" dirty="0">
+                <a:sym typeface="Wingdings" pitchFamily="2" charset="2"/>
+              </a:rPr>
+              <a:t> </a:t>
+            </a:r>
+            <a:r>
+              <a:rPr lang="de-DE" dirty="0" err="1">
+                <a:sym typeface="Wingdings" pitchFamily="2" charset="2"/>
+              </a:rPr>
+              <a:t>single</a:t>
+            </a:r>
+            <a:r>
+              <a:rPr lang="de-DE" dirty="0">
+                <a:sym typeface="Wingdings" pitchFamily="2" charset="2"/>
+              </a:rPr>
+              <a:t> </a:t>
+            </a:r>
+            <a:r>
+              <a:rPr lang="de-DE" dirty="0" err="1">
+                <a:sym typeface="Wingdings" pitchFamily="2" charset="2"/>
+              </a:rPr>
+              <a:t>phase</a:t>
+            </a:r>
+            <a:r>
+              <a:rPr lang="de-DE" dirty="0">
+                <a:sym typeface="Wingdings" pitchFamily="2" charset="2"/>
+              </a:rPr>
+              <a:t> </a:t>
+            </a:r>
+            <a:r>
+              <a:rPr lang="de-DE" dirty="0" err="1">
+                <a:sym typeface="Wingdings" pitchFamily="2" charset="2"/>
+              </a:rPr>
+              <a:t>solution</a:t>
+            </a:r>
+            <a:r>
+              <a:rPr lang="de-DE" dirty="0">
+                <a:sym typeface="Wingdings" pitchFamily="2" charset="2"/>
+              </a:rPr>
+              <a:t> </a:t>
+            </a:r>
+            <a:r>
+              <a:rPr lang="de-DE" dirty="0" err="1">
+                <a:sym typeface="Wingdings" pitchFamily="2" charset="2"/>
+              </a:rPr>
+              <a:t>is</a:t>
+            </a:r>
+            <a:r>
+              <a:rPr lang="de-DE" dirty="0">
+                <a:sym typeface="Wingdings" pitchFamily="2" charset="2"/>
+              </a:rPr>
+              <a:t> </a:t>
+            </a:r>
+            <a:r>
+              <a:rPr lang="de-DE" dirty="0" err="1">
+                <a:sym typeface="Wingdings" pitchFamily="2" charset="2"/>
+              </a:rPr>
+              <a:t>vapor</a:t>
+            </a:r>
+            <a:r>
+              <a:rPr lang="de-DE" dirty="0">
+                <a:sym typeface="Wingdings" pitchFamily="2" charset="2"/>
+              </a:rPr>
+              <a:t> </a:t>
+            </a:r>
+            <a:r>
+              <a:rPr lang="de-DE" dirty="0" err="1">
+                <a:sym typeface="Wingdings" pitchFamily="2" charset="2"/>
+              </a:rPr>
+              <a:t>or</a:t>
+            </a:r>
+            <a:r>
+              <a:rPr lang="de-DE" dirty="0">
+                <a:sym typeface="Wingdings" pitchFamily="2" charset="2"/>
+              </a:rPr>
+              <a:t> liquid </a:t>
+            </a:r>
+            <a:r>
+              <a:rPr lang="de-DE" dirty="0" err="1">
+                <a:sym typeface="Wingdings" pitchFamily="2" charset="2"/>
+              </a:rPr>
+              <a:t>is</a:t>
+            </a:r>
+            <a:r>
+              <a:rPr lang="de-DE" dirty="0">
+                <a:sym typeface="Wingdings" pitchFamily="2" charset="2"/>
+              </a:rPr>
+              <a:t> still </a:t>
+            </a:r>
+            <a:r>
+              <a:rPr lang="de-DE" dirty="0" err="1">
+                <a:sym typeface="Wingdings" pitchFamily="2" charset="2"/>
+              </a:rPr>
+              <a:t>needed</a:t>
+            </a:r>
+            <a:r>
+              <a:rPr lang="de-DE" dirty="0">
+                <a:sym typeface="Wingdings" pitchFamily="2" charset="2"/>
+              </a:rPr>
+              <a:t>, </a:t>
+            </a:r>
+            <a:r>
+              <a:rPr lang="de-DE" dirty="0" err="1">
+                <a:sym typeface="Wingdings" pitchFamily="2" charset="2"/>
+              </a:rPr>
+              <a:t>for</a:t>
+            </a:r>
+            <a:r>
+              <a:rPr lang="de-DE" dirty="0">
+                <a:sym typeface="Wingdings" pitchFamily="2" charset="2"/>
+              </a:rPr>
+              <a:t> VLE </a:t>
+            </a:r>
+            <a:r>
+              <a:rPr lang="de-DE" dirty="0" err="1">
+                <a:sym typeface="Wingdings" pitchFamily="2" charset="2"/>
+              </a:rPr>
+              <a:t>it‘s</a:t>
+            </a:r>
+            <a:r>
+              <a:rPr lang="de-DE" dirty="0">
+                <a:sym typeface="Wingdings" pitchFamily="2" charset="2"/>
+              </a:rPr>
+              <a:t> not a </a:t>
+            </a:r>
+            <a:r>
+              <a:rPr lang="de-DE" dirty="0" err="1">
+                <a:sym typeface="Wingdings" pitchFamily="2" charset="2"/>
+              </a:rPr>
+              <a:t>problem</a:t>
+            </a:r>
+            <a:r>
+              <a:rPr lang="de-DE" dirty="0">
+                <a:sym typeface="Wingdings" pitchFamily="2" charset="2"/>
+              </a:rPr>
+              <a:t> </a:t>
+            </a:r>
+            <a:r>
+              <a:rPr lang="de-DE" dirty="0" err="1">
+                <a:sym typeface="Wingdings" pitchFamily="2" charset="2"/>
+              </a:rPr>
+              <a:t>as</a:t>
+            </a:r>
+            <a:r>
+              <a:rPr lang="de-DE" dirty="0">
+                <a:sym typeface="Wingdings" pitchFamily="2" charset="2"/>
+              </a:rPr>
+              <a:t> </a:t>
+            </a:r>
+            <a:r>
+              <a:rPr lang="de-DE" dirty="0" err="1">
+                <a:sym typeface="Wingdings" pitchFamily="2" charset="2"/>
+              </a:rPr>
+              <a:t>compressibility</a:t>
+            </a:r>
+            <a:r>
+              <a:rPr lang="de-DE" dirty="0">
+                <a:sym typeface="Wingdings" pitchFamily="2" charset="2"/>
+              </a:rPr>
+              <a:t> </a:t>
+            </a:r>
+            <a:r>
+              <a:rPr lang="de-DE" dirty="0" err="1">
+                <a:sym typeface="Wingdings" pitchFamily="2" charset="2"/>
+              </a:rPr>
+              <a:t>factors</a:t>
+            </a:r>
+            <a:r>
+              <a:rPr lang="de-DE" dirty="0">
+                <a:sym typeface="Wingdings" pitchFamily="2" charset="2"/>
+              </a:rPr>
+              <a:t> Z</a:t>
+            </a:r>
+            <a:r>
+              <a:rPr lang="de-DE" baseline="-25000" dirty="0">
+                <a:sym typeface="Wingdings" pitchFamily="2" charset="2"/>
+              </a:rPr>
+              <a:t>L</a:t>
+            </a:r>
+            <a:r>
+              <a:rPr lang="de-DE" dirty="0">
+                <a:sym typeface="Wingdings" pitchFamily="2" charset="2"/>
+              </a:rPr>
+              <a:t> and </a:t>
+            </a:r>
+            <a:r>
+              <a:rPr lang="de-DE" dirty="0" err="1">
+                <a:sym typeface="Wingdings" pitchFamily="2" charset="2"/>
+              </a:rPr>
+              <a:t>Z</a:t>
+            </a:r>
+            <a:r>
+              <a:rPr lang="de-DE" baseline="-25000" dirty="0" err="1">
+                <a:sym typeface="Wingdings" pitchFamily="2" charset="2"/>
+              </a:rPr>
+              <a:t>v</a:t>
+            </a:r>
+            <a:r>
+              <a:rPr lang="de-DE" dirty="0">
+                <a:sym typeface="Wingdings" pitchFamily="2" charset="2"/>
+              </a:rPr>
+              <a:t> </a:t>
+            </a:r>
+            <a:r>
+              <a:rPr lang="de-DE" dirty="0" err="1">
+                <a:sym typeface="Wingdings" pitchFamily="2" charset="2"/>
+              </a:rPr>
+              <a:t>can</a:t>
+            </a:r>
+            <a:r>
+              <a:rPr lang="de-DE" dirty="0">
+                <a:sym typeface="Wingdings" pitchFamily="2" charset="2"/>
+              </a:rPr>
+              <a:t> </a:t>
+            </a:r>
+            <a:r>
+              <a:rPr lang="de-DE" dirty="0" err="1">
+                <a:sym typeface="Wingdings" pitchFamily="2" charset="2"/>
+              </a:rPr>
+              <a:t>easily</a:t>
+            </a:r>
+            <a:r>
+              <a:rPr lang="de-DE" dirty="0">
+                <a:sym typeface="Wingdings" pitchFamily="2" charset="2"/>
+              </a:rPr>
+              <a:t> </a:t>
+            </a:r>
+            <a:r>
+              <a:rPr lang="de-DE" dirty="0" err="1">
+                <a:sym typeface="Wingdings" pitchFamily="2" charset="2"/>
+              </a:rPr>
+              <a:t>be</a:t>
+            </a:r>
+            <a:r>
+              <a:rPr lang="de-DE" dirty="0">
+                <a:sym typeface="Wingdings" pitchFamily="2" charset="2"/>
+              </a:rPr>
+              <a:t> </a:t>
+            </a:r>
+            <a:r>
+              <a:rPr lang="de-DE" dirty="0" err="1">
+                <a:sym typeface="Wingdings" pitchFamily="2" charset="2"/>
+              </a:rPr>
+              <a:t>compared</a:t>
+            </a:r>
+            <a:endParaRPr lang="de-DE" dirty="0">
+              <a:sym typeface="Wingdings" pitchFamily="2" charset="2"/>
+            </a:endParaRPr>
+          </a:p>
+          <a:p>
+            <a:pPr lvl="1"/>
+            <a:endParaRPr lang="de-DE" dirty="0"/>
+          </a:p>
+        </p:txBody>
+      </p:sp>
+    </p:spTree>
+    <p:extLst>
+      <p:ext uri="{BB962C8B-B14F-4D97-AF65-F5344CB8AC3E}">
+        <p14:creationId xmlns:p14="http://schemas.microsoft.com/office/powerpoint/2010/main" val="2324697207"/>
+      </p:ext>
+    </p:extLst>
+  </p:cSld>
+  <p:clrMapOvr>
+    <a:masterClrMapping/>
+  </p:clrMapOvr>
+</p:sld>
+</file>
+
+<file path=ppt/slides/slide11.xml><?xml version="1.0" encoding="utf-8"?>
+<p:sld xmlns:a="http://schemas.openxmlformats.org/drawingml/2006/main" xmlns:r="http://schemas.openxmlformats.org/officeDocument/2006/relationships" xmlns:p="http://schemas.openxmlformats.org/presentationml/2006/main">
+  <p:cSld>
+    <p:spTree>
+      <p:nvGrpSpPr>
+        <p:cNvPr id="1" name=""/>
+        <p:cNvGrpSpPr/>
+        <p:nvPr/>
+      </p:nvGrpSpPr>
+      <p:grpSpPr>
+        <a:xfrm>
+          <a:off x="0" y="0"/>
+          <a:ext cx="0" cy="0"/>
+          <a:chOff x="0" y="0"/>
+          <a:chExt cx="0" cy="0"/>
+        </a:xfrm>
+      </p:grpSpPr>
+      <p:sp>
+        <p:nvSpPr>
+          <p:cNvPr id="4" name="Titel 3"/>
+          <p:cNvSpPr>
+            <a:spLocks noGrp="1"/>
+          </p:cNvSpPr>
+          <p:nvPr>
+            <p:ph type="ctrTitle"/>
+          </p:nvPr>
+        </p:nvSpPr>
+        <p:spPr/>
+        <p:txBody>
+          <a:bodyPr/>
+          <a:lstStyle/>
+          <a:p>
+            <a:r>
+              <a:rPr lang="en-US" dirty="0"/>
+              <a:t>Acknowledgement</a:t>
+            </a:r>
+          </a:p>
+        </p:txBody>
+      </p:sp>
+      <p:sp>
+        <p:nvSpPr>
+          <p:cNvPr id="5" name="Untertitel 4"/>
+          <p:cNvSpPr>
+            <a:spLocks noGrp="1"/>
+          </p:cNvSpPr>
+          <p:nvPr>
+            <p:ph type="subTitle" idx="1"/>
+          </p:nvPr>
+        </p:nvSpPr>
+        <p:spPr/>
+        <p:txBody>
+          <a:bodyPr>
+            <a:normAutofit/>
+          </a:bodyPr>
+          <a:lstStyle/>
+          <a:p>
+            <a:pPr algn="l">
+              <a:tabLst>
+                <a:tab pos="1255713" algn="l"/>
+              </a:tabLst>
+            </a:pPr>
+            <a:r>
+              <a:rPr lang="en-US" dirty="0"/>
+              <a:t>People:	Names</a:t>
+            </a:r>
+          </a:p>
+          <a:p>
+            <a:pPr algn="l"/>
+            <a:endParaRPr lang="en-US" dirty="0"/>
+          </a:p>
+          <a:p>
+            <a:pPr algn="l">
+              <a:tabLst>
+                <a:tab pos="1255713" algn="l"/>
+              </a:tabLst>
+            </a:pPr>
+            <a:r>
+              <a:rPr lang="en-US" dirty="0"/>
+              <a:t>Funding:	Sources</a:t>
+            </a:r>
+          </a:p>
+        </p:txBody>
+      </p:sp>
+    </p:spTree>
+    <p:extLst>
+      <p:ext uri="{BB962C8B-B14F-4D97-AF65-F5344CB8AC3E}">
+        <p14:creationId xmlns:p14="http://schemas.microsoft.com/office/powerpoint/2010/main" val="4173971235"/>
+      </p:ext>
+    </p:extLst>
+  </p:cSld>
+  <p:clrMapOvr>
+    <a:masterClrMapping/>
+  </p:clrMapOvr>
+</p:sld>
+</file>
+
 <file path=ppt/slides/slide2.xml><?xml version="1.0" encoding="utf-8"?>
 <p:sld xmlns:a="http://schemas.openxmlformats.org/drawingml/2006/main" xmlns:r="http://schemas.openxmlformats.org/officeDocument/2006/relationships" xmlns:p="http://schemas.openxmlformats.org/presentationml/2006/main">
   <p:cSld>
@@ -3003,7 +4418,7 @@
               <a:rPr lang="en-US" dirty="0">
                 <a:sym typeface="Wingdings" pitchFamily="2" charset="2"/>
               </a:rPr>
-              <a:t>  calculation of fugacity coefficients, two functions one for VLE and one for single phase</a:t>
+              <a:t>  calculation of fugacity coefficients, two functions: one for VLE and one for single phase</a:t>
             </a:r>
           </a:p>
           <a:p>
@@ -3163,9 +4578,6 @@
           <a:bodyPr/>
           <a:lstStyle/>
           <a:p>
-            <a:pPr marL="0" indent="0">
-              <a:buNone/>
-            </a:pPr>
             <a:r>
               <a:rPr lang="de-DE" dirty="0"/>
               <a:t>Michelsen Part I - </a:t>
@@ -3183,9 +4595,6 @@
             </a:endParaRPr>
           </a:p>
           <a:p>
-            <a:pPr marL="0" indent="0">
-              <a:buNone/>
-            </a:pPr>
             <a:r>
               <a:rPr lang="de-DE" b="0" i="0" u="none" strike="noStrike" dirty="0">
                 <a:effectLst/>
@@ -3205,110 +4614,107 @@
             </a:endParaRPr>
           </a:p>
           <a:p>
+            <a:r>
+              <a:rPr lang="de-DE" b="0" i="0" u="none" strike="noStrike" dirty="0">
+                <a:effectLst/>
+              </a:rPr>
+              <a:t>C. </a:t>
+            </a:r>
+            <a:r>
+              <a:rPr lang="de-DE" b="0" i="0" u="none" strike="noStrike" dirty="0" err="1">
+                <a:effectLst/>
+              </a:rPr>
+              <a:t>Tsanas</a:t>
+            </a:r>
+            <a:r>
+              <a:rPr lang="de-DE" b="0" i="0" u="none" strike="noStrike" dirty="0">
+                <a:effectLst/>
+              </a:rPr>
+              <a:t> 2018 – </a:t>
+            </a:r>
+            <a:r>
+              <a:rPr lang="de-DE" b="0" i="0" u="none" strike="noStrike" dirty="0" err="1">
+                <a:effectLst/>
+              </a:rPr>
+              <a:t>Simulatenous</a:t>
+            </a:r>
+            <a:r>
+              <a:rPr lang="de-DE" b="0" i="0" u="none" strike="noStrike" dirty="0">
+                <a:effectLst/>
+              </a:rPr>
+              <a:t> Chemical and Phase Equilibrium </a:t>
+            </a:r>
+            <a:r>
+              <a:rPr lang="de-DE" b="0" i="0" u="none" strike="noStrike" dirty="0" err="1">
+                <a:effectLst/>
+              </a:rPr>
+              <a:t>Calculations</a:t>
+            </a:r>
+            <a:r>
+              <a:rPr lang="de-DE" b="0" i="0" u="none" strike="noStrike" dirty="0">
+                <a:effectLst/>
+              </a:rPr>
+              <a:t> </a:t>
+            </a:r>
+            <a:r>
+              <a:rPr lang="de-DE" b="0" i="0" u="none" strike="noStrike" dirty="0" err="1">
+                <a:effectLst/>
+              </a:rPr>
+              <a:t>with</a:t>
+            </a:r>
+            <a:r>
+              <a:rPr lang="de-DE" b="0" i="0" u="none" strike="noStrike" dirty="0">
+                <a:effectLst/>
+              </a:rPr>
+              <a:t> Non-</a:t>
+            </a:r>
+            <a:r>
+              <a:rPr lang="de-DE" b="0" i="0" u="none" strike="noStrike" dirty="0" err="1">
+                <a:effectLst/>
+              </a:rPr>
+              <a:t>Stoichiometric</a:t>
+            </a:r>
+            <a:r>
+              <a:rPr lang="de-DE" b="0" i="0" u="none" strike="noStrike" dirty="0">
+                <a:effectLst/>
+              </a:rPr>
+              <a:t> Method (Chapter 3.1.3 </a:t>
+            </a:r>
+            <a:r>
+              <a:rPr lang="de-DE" b="0" i="0" u="none" strike="noStrike" dirty="0" err="1">
+                <a:effectLst/>
+              </a:rPr>
+              <a:t>Stability</a:t>
+            </a:r>
+            <a:r>
+              <a:rPr lang="de-DE" b="0" i="0" u="none" strike="noStrike" dirty="0">
+                <a:effectLst/>
+              </a:rPr>
+              <a:t> </a:t>
+            </a:r>
+            <a:r>
+              <a:rPr lang="de-DE" b="0" i="0" u="none" strike="noStrike" dirty="0" err="1">
+                <a:effectLst/>
+              </a:rPr>
+              <a:t>analysis</a:t>
+            </a:r>
+            <a:r>
+              <a:rPr lang="de-DE" b="0" i="0" u="none" strike="noStrike" dirty="0">
+                <a:effectLst/>
+              </a:rPr>
+              <a:t>)</a:t>
+            </a:r>
+          </a:p>
+          <a:p>
             <a:pPr marL="0" indent="0">
               <a:buNone/>
             </a:pPr>
             <a:r>
               <a:rPr lang="de-DE" b="0" i="0" u="none" strike="noStrike" dirty="0">
                 <a:effectLst/>
-              </a:rPr>
-              <a:t>C. </a:t>
-            </a:r>
-            <a:r>
-              <a:rPr lang="de-DE" b="0" i="0" u="none" strike="noStrike" dirty="0" err="1">
-                <a:effectLst/>
-              </a:rPr>
-              <a:t>Tsanas</a:t>
-            </a:r>
-            <a:r>
-              <a:rPr lang="de-DE" b="0" i="0" u="none" strike="noStrike" dirty="0">
-                <a:effectLst/>
-              </a:rPr>
-              <a:t> 2018 – </a:t>
-            </a:r>
-            <a:r>
-              <a:rPr lang="de-DE" b="0" i="0" u="none" strike="noStrike" dirty="0" err="1">
-                <a:effectLst/>
-              </a:rPr>
-              <a:t>Simulatenous</a:t>
-            </a:r>
-            <a:r>
-              <a:rPr lang="de-DE" b="0" i="0" u="none" strike="noStrike" dirty="0">
-                <a:effectLst/>
-              </a:rPr>
-              <a:t> Chemical and Phase Equilibrium </a:t>
-            </a:r>
-            <a:r>
-              <a:rPr lang="de-DE" b="0" i="0" u="none" strike="noStrike" dirty="0" err="1">
-                <a:effectLst/>
-              </a:rPr>
-              <a:t>Calculations</a:t>
-            </a:r>
-            <a:r>
-              <a:rPr lang="de-DE" b="0" i="0" u="none" strike="noStrike" dirty="0">
-                <a:effectLst/>
-              </a:rPr>
-              <a:t> </a:t>
-            </a:r>
-            <a:r>
-              <a:rPr lang="de-DE" b="0" i="0" u="none" strike="noStrike" dirty="0" err="1">
-                <a:effectLst/>
-              </a:rPr>
-              <a:t>with</a:t>
-            </a:r>
-            <a:r>
-              <a:rPr lang="de-DE" b="0" i="0" u="none" strike="noStrike" dirty="0">
-                <a:effectLst/>
-              </a:rPr>
-              <a:t> Non-</a:t>
-            </a:r>
-            <a:r>
-              <a:rPr lang="de-DE" b="0" i="0" u="none" strike="noStrike" dirty="0" err="1">
-                <a:effectLst/>
-              </a:rPr>
-              <a:t>Stoichiometric</a:t>
-            </a:r>
-            <a:r>
-              <a:rPr lang="de-DE" b="0" i="0" u="none" strike="noStrike" dirty="0">
-                <a:effectLst/>
-              </a:rPr>
-              <a:t> Method (Chapter 3.1.3 </a:t>
-            </a:r>
-            <a:r>
-              <a:rPr lang="de-DE" b="0" i="0" u="none" strike="noStrike" dirty="0" err="1">
-                <a:effectLst/>
-              </a:rPr>
-              <a:t>Stability</a:t>
-            </a:r>
-            <a:r>
-              <a:rPr lang="de-DE" b="0" i="0" u="none" strike="noStrike" dirty="0">
-                <a:effectLst/>
-              </a:rPr>
-              <a:t> </a:t>
-            </a:r>
-            <a:r>
-              <a:rPr lang="de-DE" b="0" i="0" u="none" strike="noStrike" dirty="0" err="1">
-                <a:effectLst/>
-              </a:rPr>
-              <a:t>analysis</a:t>
-            </a:r>
-            <a:r>
-              <a:rPr lang="de-DE" b="0" i="0" u="none" strike="noStrike" dirty="0">
-                <a:effectLst/>
-              </a:rPr>
-              <a:t>)</a:t>
-            </a:r>
-          </a:p>
-          <a:p>
-            <a:pPr marL="0" indent="0">
-              <a:buNone/>
-            </a:pPr>
-            <a:r>
-              <a:rPr lang="de-DE" b="0" i="0" u="none" strike="noStrike" dirty="0">
-                <a:effectLst/>
-                <a:sym typeface="Wingdings" pitchFamily="2" charset="2"/>
-              </a:rPr>
-              <a:t> Here a </a:t>
+                <a:sym typeface="Wingdings" pitchFamily="2" charset="2"/>
+              </a:rPr>
+              <a:t>	 Here a </a:t>
             </a:r>
             <a:r>
               <a:rPr lang="de-DE" b="0" i="0" u="none" strike="noStrike" dirty="0" err="1">
@@ -3419,9 +4825,6 @@
             </a:endParaRPr>
           </a:p>
           <a:p>
-            <a:pPr marL="0" indent="0">
-              <a:buNone/>
-            </a:pPr>
             <a:r>
               <a:rPr lang="de-DE" dirty="0"/>
               <a:t>Michelsen 2007 – </a:t>
@@ -4031,7 +5434,39 @@
           <a:p>
             <a:r>
               <a:rPr lang="de-DE" dirty="0"/>
-              <a:t>4. Set N</a:t>
+              <a:t>4. </a:t>
+            </a:r>
+            <a:r>
+              <a:rPr lang="de-DE" dirty="0" err="1"/>
+              <a:t>If</a:t>
+            </a:r>
+            <a:r>
+              <a:rPr lang="de-DE" dirty="0"/>
+              <a:t> </a:t>
+            </a:r>
+            <a:r>
+              <a:rPr lang="de-DE" dirty="0" err="1"/>
+              <a:t>solution</a:t>
+            </a:r>
+            <a:r>
+              <a:rPr lang="de-DE" dirty="0"/>
+              <a:t> </a:t>
+            </a:r>
+            <a:r>
+              <a:rPr lang="de-DE" dirty="0" err="1"/>
+              <a:t>unstable</a:t>
+            </a:r>
+            <a:r>
+              <a:rPr lang="de-DE" dirty="0"/>
+              <a:t>, </a:t>
+            </a:r>
+            <a:r>
+              <a:rPr lang="de-DE" dirty="0" err="1"/>
+              <a:t>set</a:t>
+            </a:r>
+            <a:r>
+              <a:rPr lang="de-DE" dirty="0"/>
+              <a:t> N</a:t>
             </a:r>
             <a:r>
               <a:rPr lang="de-DE" baseline="-25000" dirty="0"/>
@@ -4651,6 +6086,11 @@
               <a:rPr lang="de-DE" dirty="0"/>
               <a:t> </a:t>
             </a:r>
+          </a:p>
+          <a:p>
+            <a:pPr marL="914400" lvl="2" indent="0">
+              <a:buNone/>
+            </a:pPr>
             <a:r>
               <a:rPr lang="de-DE" dirty="0">
                 <a:sym typeface="Wingdings" pitchFamily="2" charset="2"/>
@@ -4691,8 +6131,29 @@
               <a:rPr lang="de-DE" dirty="0">
                 <a:sym typeface="Wingdings" pitchFamily="2" charset="2"/>
               </a:rPr>
-              <a:t>.</a:t>
-            </a:r>
+              <a:t> in </a:t>
+            </a:r>
+            <a:r>
+              <a:rPr lang="de-DE" dirty="0" err="1">
+                <a:sym typeface="Wingdings" pitchFamily="2" charset="2"/>
+              </a:rPr>
+              <a:t>chemical</a:t>
+            </a:r>
+            <a:r>
+              <a:rPr lang="de-DE" dirty="0">
+                <a:sym typeface="Wingdings" pitchFamily="2" charset="2"/>
+              </a:rPr>
+              <a:t> </a:t>
+            </a:r>
+            <a:r>
+              <a:rPr lang="de-DE" dirty="0" err="1">
+                <a:sym typeface="Wingdings" pitchFamily="2" charset="2"/>
+              </a:rPr>
+              <a:t>equilibrium</a:t>
+            </a:r>
+            <a:endParaRPr lang="de-DE" dirty="0">
+              <a:sym typeface="Wingdings" pitchFamily="2" charset="2"/>
+            </a:endParaRPr>
           </a:p>
           <a:p>
             <a:pPr lvl="1">
@@ -5071,7 +6532,39 @@
           <a:p>
             <a:r>
               <a:rPr lang="de-DE" dirty="0" err="1"/>
-              <a:t>Literature</a:t>
+              <a:t>Comparison</a:t>
+            </a:r>
+            <a:r>
+              <a:rPr lang="de-DE" dirty="0"/>
+              <a:t> </a:t>
+            </a:r>
+            <a:r>
+              <a:rPr lang="de-DE" dirty="0" err="1"/>
+              <a:t>of</a:t>
+            </a:r>
+            <a:r>
+              <a:rPr lang="de-DE" dirty="0"/>
+              <a:t> GEM </a:t>
+            </a:r>
+            <a:r>
+              <a:rPr lang="de-DE" dirty="0" err="1"/>
+              <a:t>model</a:t>
+            </a:r>
+            <a:r>
+              <a:rPr lang="de-DE" dirty="0"/>
+              <a:t> </a:t>
+            </a:r>
+            <a:r>
+              <a:rPr lang="de-DE" dirty="0" err="1"/>
+              <a:t>with</a:t>
+            </a:r>
+            <a:r>
+              <a:rPr lang="de-DE" dirty="0"/>
+              <a:t> </a:t>
+            </a:r>
+            <a:r>
+              <a:rPr lang="de-DE" dirty="0" err="1"/>
+              <a:t>literature</a:t>
             </a:r>
             <a:r>
               <a:rPr lang="de-DE" dirty="0"/>
@@ -5080,22 +6573,6 @@
             <a:r>
               <a:rPr lang="de-DE" dirty="0" err="1"/>
               <a:t>data</a:t>
-            </a:r>
-            <a:r>
-              <a:rPr lang="de-DE" dirty="0"/>
-              <a:t> </a:t>
-            </a:r>
-            <a:r>
-              <a:rPr lang="de-DE" dirty="0" err="1"/>
-              <a:t>for</a:t>
-            </a:r>
-            <a:r>
-              <a:rPr lang="de-DE" dirty="0"/>
-              <a:t> Methanol </a:t>
-            </a:r>
-            <a:r>
-              <a:rPr lang="de-DE" dirty="0" err="1"/>
-              <a:t>equilibrium</a:t>
             </a:r>
             <a:endParaRPr lang="de-DE" dirty="0"/>
           </a:p>
@@ -5246,10 +6723,172 @@
           <a:p>
             <a:endParaRPr lang="de-DE" sz="1400" dirty="0"/>
           </a:p>
-          <a:p>
-            <a:endParaRPr lang="de-DE" sz="1400" dirty="0"/>
-          </a:p>
-          <a:p>
+        </p:txBody>
+      </p:sp>
+      <p:pic>
+        <p:nvPicPr>
+          <p:cNvPr id="5" name="Grafik 4" descr="Ein Bild, das Text, Screenshot, Zahl, Schrift enthält.&#10;&#10;KI-generierte Inhalte können fehlerhaft sein.">
+            <a:extLst>
+              <a:ext uri="{FF2B5EF4-FFF2-40B4-BE49-F238E27FC236}">
+                <a16:creationId xmlns:a16="http://schemas.microsoft.com/office/drawing/2014/main" id="{9C1FC6A5-EC04-2634-D656-034C1849AEA8}"/>
+              </a:ext>
+            </a:extLst>
+          </p:cNvPr>
+          <p:cNvPicPr>
+            <a:picLocks noChangeAspect="1"/>
+          </p:cNvPicPr>
+          <p:nvPr/>
+        </p:nvPicPr>
+        <p:blipFill>
+          <a:blip r:embed="rId4">
+            <a:extLst>
+              <a:ext uri="{28A0092B-C50C-407E-A947-70E740481C1C}">
+                <a14:useLocalDpi xmlns:a14="http://schemas.microsoft.com/office/drawing/2010/main" val="0"/>
+              </a:ext>
+            </a:extLst>
+          </a:blip>
+          <a:stretch>
+            <a:fillRect/>
+          </a:stretch>
+        </p:blipFill>
+        <p:spPr>
+          <a:xfrm>
+            <a:off x="695400" y="2132856"/>
+            <a:ext cx="5036161" cy="4446151"/>
+          </a:xfrm>
+          <a:prstGeom prst="rect">
+            <a:avLst/>
+          </a:prstGeom>
+        </p:spPr>
+      </p:pic>
+      <p:pic>
+        <p:nvPicPr>
+          <p:cNvPr id="7" name="Grafik 6" descr="Ein Bild, das Text, Screenshot, Software enthält.&#10;&#10;KI-generierte Inhalte können fehlerhaft sein.">
+            <a:extLst>
+              <a:ext uri="{FF2B5EF4-FFF2-40B4-BE49-F238E27FC236}">
+                <a16:creationId xmlns:a16="http://schemas.microsoft.com/office/drawing/2014/main" id="{6418365D-9F0D-60AD-323E-D3F344AF4BE8}"/>
+              </a:ext>
+            </a:extLst>
+          </p:cNvPr>
+          <p:cNvPicPr>
+            <a:picLocks noChangeAspect="1"/>
+          </p:cNvPicPr>
+          <p:nvPr/>
+        </p:nvPicPr>
+        <p:blipFill>
+          <a:blip r:embed="rId5">
+            <a:extLst>
+              <a:ext uri="{28A0092B-C50C-407E-A947-70E740481C1C}">
+                <a14:useLocalDpi xmlns:a14="http://schemas.microsoft.com/office/drawing/2010/main" val="0"/>
+              </a:ext>
+            </a:extLst>
+          </a:blip>
+          <a:stretch>
+            <a:fillRect/>
+          </a:stretch>
+        </p:blipFill>
+        <p:spPr>
+          <a:xfrm>
+            <a:off x="5812489" y="2114128"/>
+            <a:ext cx="3739895" cy="4160943"/>
+          </a:xfrm>
+          <a:prstGeom prst="rect">
+            <a:avLst/>
+          </a:prstGeom>
+        </p:spPr>
+      </p:pic>
+      <p:sp>
+        <p:nvSpPr>
+          <p:cNvPr id="8" name="Textfeld 7">
+            <a:extLst>
+              <a:ext uri="{FF2B5EF4-FFF2-40B4-BE49-F238E27FC236}">
+                <a16:creationId xmlns:a16="http://schemas.microsoft.com/office/drawing/2014/main" id="{3CD967A5-B3A7-BE95-E2ED-BE498889BCAF}"/>
+              </a:ext>
+            </a:extLst>
+          </p:cNvPr>
+          <p:cNvSpPr txBox="1"/>
+          <p:nvPr/>
+        </p:nvSpPr>
+        <p:spPr>
+          <a:xfrm>
+            <a:off x="9768408" y="2114128"/>
+            <a:ext cx="2088232" cy="1754326"/>
+          </a:xfrm>
+          <a:prstGeom prst="rect">
+            <a:avLst/>
+          </a:prstGeom>
+          <a:noFill/>
+        </p:spPr>
+        <p:txBody>
+          <a:bodyPr wrap="square" rtlCol="0">
+            <a:spAutoFit/>
+          </a:bodyPr>
+          <a:lstStyle/>
+          <a:p>
+            <a:r>
+              <a:rPr lang="de-DE" dirty="0"/>
+              <a:t>Van </a:t>
+            </a:r>
+            <a:r>
+              <a:rPr lang="de-DE" dirty="0" err="1"/>
+              <a:t>Bennekom</a:t>
+            </a:r>
+            <a:r>
+              <a:rPr lang="de-DE" dirty="0"/>
+              <a:t> 2012 – Table S.3 (SI); </a:t>
+            </a:r>
+            <a:r>
+              <a:rPr lang="de-DE" dirty="0" err="1"/>
+              <a:t>comparison</a:t>
+            </a:r>
+            <a:r>
+              <a:rPr lang="de-DE" dirty="0"/>
+              <a:t> </a:t>
+            </a:r>
+            <a:r>
+              <a:rPr lang="de-DE" dirty="0" err="1"/>
+              <a:t>for</a:t>
+            </a:r>
+            <a:r>
+              <a:rPr lang="de-DE" dirty="0"/>
+              <a:t> a </a:t>
+            </a:r>
+            <a:r>
+              <a:rPr lang="de-DE" dirty="0" err="1"/>
+              <a:t>given</a:t>
+            </a:r>
+            <a:r>
+              <a:rPr lang="de-DE" dirty="0"/>
+              <a:t> </a:t>
+            </a:r>
+            <a:r>
+              <a:rPr lang="de-DE" dirty="0" err="1"/>
+              <a:t>pressure</a:t>
+            </a:r>
+            <a:r>
+              <a:rPr lang="de-DE" dirty="0"/>
+              <a:t>, </a:t>
+            </a:r>
+            <a:r>
+              <a:rPr lang="de-DE" dirty="0" err="1"/>
+              <a:t>temperature</a:t>
+            </a:r>
+            <a:r>
+              <a:rPr lang="de-DE" dirty="0"/>
+              <a:t> and </a:t>
+            </a:r>
+            <a:r>
+              <a:rPr lang="de-DE" dirty="0" err="1"/>
+              <a:t>inlet</a:t>
+            </a:r>
+            <a:r>
+              <a:rPr lang="de-DE" dirty="0"/>
+              <a:t> </a:t>
+            </a:r>
+            <a:r>
+              <a:rPr lang="de-DE" dirty="0" err="1"/>
+              <a:t>composition</a:t>
+            </a:r>
             <a:endParaRPr lang="de-DE" dirty="0"/>
           </a:p>
         </p:txBody>
@@ -5289,7 +6928,7 @@
           <p:cNvPr id="2" name="Titel 1">
             <a:extLst>
               <a:ext uri="{FF2B5EF4-FFF2-40B4-BE49-F238E27FC236}">
-                <a16:creationId xmlns:a16="http://schemas.microsoft.com/office/drawing/2014/main" id="{6C03BE77-D8C4-AF59-A2BB-92C450017A80}"/>
+                <a16:creationId xmlns:a16="http://schemas.microsoft.com/office/drawing/2014/main" id="{FAD53050-ECAF-C04C-23B5-E27C6C0FDFAA}"/>
               </a:ext>
             </a:extLst>
           </p:cNvPr>
@@ -5306,1283 +6945,104 @@
           <a:lstStyle/>
           <a:p>
             <a:r>
-              <a:rPr lang="de-DE" dirty="0" err="1"/>
-              <a:t>Current</a:t>
-            </a:r>
-            <a:r>
-              <a:rPr lang="de-DE" dirty="0"/>
-              <a:t> </a:t>
-            </a:r>
-            <a:r>
-              <a:rPr lang="de-DE" dirty="0" err="1"/>
-              <a:t>challenges</a:t>
-            </a:r>
-            <a:r>
-              <a:rPr lang="de-DE" dirty="0"/>
-              <a:t>/</a:t>
-            </a:r>
-            <a:r>
-              <a:rPr lang="de-DE" dirty="0" err="1"/>
-              <a:t>problems</a:t>
-            </a:r>
-            <a:endParaRPr lang="de-DE" dirty="0"/>
+              <a:rPr lang="de-DE" dirty="0"/>
+              <a:t>Further </a:t>
+            </a:r>
+            <a:r>
+              <a:rPr lang="de-DE" dirty="0" err="1"/>
+              <a:t>literature</a:t>
+            </a:r>
+            <a:r>
+              <a:rPr lang="de-DE" dirty="0"/>
+              <a:t> </a:t>
+            </a:r>
+            <a:r>
+              <a:rPr lang="de-DE" dirty="0" err="1"/>
+              <a:t>comparisons</a:t>
+            </a:r>
+            <a:r>
+              <a:rPr lang="de-DE" dirty="0"/>
+              <a:t> – Van </a:t>
+            </a:r>
+            <a:r>
+              <a:rPr lang="de-DE" dirty="0" err="1"/>
+              <a:t>Bennekom</a:t>
+            </a:r>
+            <a:r>
+              <a:rPr lang="de-DE" dirty="0"/>
+              <a:t> 2012 Figure 8</a:t>
+            </a:r>
           </a:p>
         </p:txBody>
       </p:sp>
-      <p:sp>
-        <p:nvSpPr>
-          <p:cNvPr id="3" name="Inhaltsplatzhalter 2">
+      <p:pic>
+        <p:nvPicPr>
+          <p:cNvPr id="5" name="Inhaltsplatzhalter 4" descr="Ein Bild, das Diagramm, Reihe, Screenshot enthält.&#10;&#10;KI-generierte Inhalte können fehlerhaft sein.">
             <a:extLst>
               <a:ext uri="{FF2B5EF4-FFF2-40B4-BE49-F238E27FC236}">
-                <a16:creationId xmlns:a16="http://schemas.microsoft.com/office/drawing/2014/main" id="{7A5CE63F-4466-613C-4CD1-D0677109B7AF}"/>
+                <a16:creationId xmlns:a16="http://schemas.microsoft.com/office/drawing/2014/main" id="{E7E25D67-ECBC-5451-721E-74A2B342D669}"/>
               </a:ext>
             </a:extLst>
           </p:cNvPr>
-          <p:cNvSpPr>
-            <a:spLocks noGrp="1"/>
-          </p:cNvSpPr>
+          <p:cNvPicPr>
+            <a:picLocks noGrp="1" noChangeAspect="1"/>
+          </p:cNvPicPr>
           <p:nvPr>
             <p:ph idx="1"/>
           </p:nvPr>
-        </p:nvSpPr>
-        <p:spPr/>
-        <p:txBody>
-          <a:bodyPr/>
-          <a:lstStyle/>
-          <a:p>
-            <a:pPr marL="457200" indent="-457200">
-              <a:buFont typeface="+mj-lt"/>
-              <a:buAutoNum type="arabicPeriod"/>
-            </a:pPr>
-            <a:r>
-              <a:rPr lang="de-DE" dirty="0"/>
-              <a:t>Computational time: </a:t>
-            </a:r>
-            <a:r>
-              <a:rPr lang="de-DE" dirty="0" err="1"/>
-              <a:t>if</a:t>
-            </a:r>
-            <a:r>
-              <a:rPr lang="de-DE" dirty="0"/>
-              <a:t> </a:t>
-            </a:r>
-            <a:r>
-              <a:rPr lang="de-DE" dirty="0" err="1"/>
-              <a:t>more</a:t>
-            </a:r>
-            <a:r>
-              <a:rPr lang="de-DE" dirty="0"/>
-              <a:t> robust </a:t>
-            </a:r>
-            <a:r>
-              <a:rPr lang="de-DE" dirty="0" err="1"/>
-              <a:t>solvers</a:t>
-            </a:r>
-            <a:r>
-              <a:rPr lang="de-DE" dirty="0"/>
-              <a:t> like </a:t>
-            </a:r>
-            <a:r>
-              <a:rPr lang="de-DE" dirty="0" err="1"/>
-              <a:t>basinhopping</a:t>
-            </a:r>
-            <a:r>
-              <a:rPr lang="de-DE" dirty="0"/>
-              <a:t> </a:t>
-            </a:r>
-            <a:r>
-              <a:rPr lang="de-DE" dirty="0" err="1"/>
-              <a:t>are</a:t>
-            </a:r>
-            <a:r>
-              <a:rPr lang="de-DE" dirty="0"/>
-              <a:t> </a:t>
-            </a:r>
-            <a:r>
-              <a:rPr lang="de-DE" dirty="0" err="1"/>
-              <a:t>used</a:t>
-            </a:r>
-            <a:r>
-              <a:rPr lang="de-DE" dirty="0"/>
-              <a:t>, </a:t>
-            </a:r>
-            <a:r>
-              <a:rPr lang="de-DE" dirty="0" err="1"/>
-              <a:t>no</a:t>
-            </a:r>
-            <a:r>
-              <a:rPr lang="de-DE" dirty="0"/>
-              <a:t> </a:t>
-            </a:r>
-            <a:r>
-              <a:rPr lang="de-DE" dirty="0" err="1"/>
-              <a:t>jumps</a:t>
-            </a:r>
-            <a:r>
-              <a:rPr lang="de-DE" dirty="0"/>
-              <a:t> in </a:t>
-            </a:r>
-            <a:r>
-              <a:rPr lang="de-DE" dirty="0" err="1"/>
-              <a:t>plots</a:t>
-            </a:r>
-            <a:r>
-              <a:rPr lang="de-DE" dirty="0"/>
-              <a:t> in </a:t>
-            </a:r>
-            <a:r>
-              <a:rPr lang="de-DE" dirty="0" err="1"/>
-              <a:t>comparison</a:t>
-            </a:r>
-            <a:r>
-              <a:rPr lang="de-DE" dirty="0"/>
-              <a:t> </a:t>
-            </a:r>
-            <a:r>
-              <a:rPr lang="de-DE" dirty="0" err="1"/>
-              <a:t>to</a:t>
-            </a:r>
-            <a:r>
-              <a:rPr lang="de-DE" dirty="0"/>
-              <a:t> </a:t>
-            </a:r>
-            <a:r>
-              <a:rPr lang="de-DE" dirty="0" err="1"/>
-              <a:t>literature</a:t>
-            </a:r>
-            <a:r>
-              <a:rPr lang="de-DE" dirty="0"/>
-              <a:t> </a:t>
-            </a:r>
-            <a:r>
-              <a:rPr lang="de-DE" dirty="0" err="1"/>
-              <a:t>data</a:t>
-            </a:r>
-            <a:r>
-              <a:rPr lang="de-DE" dirty="0"/>
-              <a:t> </a:t>
-            </a:r>
-            <a:r>
-              <a:rPr lang="de-DE" dirty="0" err="1"/>
-              <a:t>were</a:t>
-            </a:r>
-            <a:r>
-              <a:rPr lang="de-DE" dirty="0"/>
-              <a:t> </a:t>
-            </a:r>
-            <a:r>
-              <a:rPr lang="de-DE" dirty="0" err="1"/>
-              <a:t>observed</a:t>
-            </a:r>
-            <a:r>
-              <a:rPr lang="de-DE" dirty="0"/>
-              <a:t>, </a:t>
-            </a:r>
-            <a:r>
-              <a:rPr lang="de-DE" dirty="0" err="1"/>
-              <a:t>plots</a:t>
-            </a:r>
-            <a:r>
-              <a:rPr lang="de-DE" dirty="0"/>
-              <a:t> </a:t>
-            </a:r>
-            <a:r>
-              <a:rPr lang="de-DE" dirty="0" err="1"/>
-              <a:t>are</a:t>
-            </a:r>
-            <a:r>
-              <a:rPr lang="de-DE" dirty="0"/>
-              <a:t> also </a:t>
-            </a:r>
-            <a:r>
-              <a:rPr lang="de-DE" dirty="0" err="1"/>
-              <a:t>stored</a:t>
-            </a:r>
-            <a:r>
-              <a:rPr lang="de-DE" dirty="0"/>
-              <a:t> in </a:t>
-            </a:r>
-            <a:r>
-              <a:rPr lang="de-DE" dirty="0" err="1"/>
-              <a:t>git</a:t>
-            </a:r>
-            <a:r>
-              <a:rPr lang="de-DE" dirty="0"/>
-              <a:t> </a:t>
-            </a:r>
-            <a:r>
-              <a:rPr lang="de-DE" dirty="0" err="1"/>
-              <a:t>repo</a:t>
-            </a:r>
-            <a:endParaRPr lang="de-DE" dirty="0"/>
-          </a:p>
-          <a:p>
-            <a:pPr lvl="1"/>
-            <a:r>
-              <a:rPr lang="de-DE" dirty="0"/>
-              <a:t>BUT: </a:t>
-            </a:r>
-            <a:r>
-              <a:rPr lang="de-DE" dirty="0" err="1"/>
-              <a:t>way</a:t>
-            </a:r>
-            <a:r>
-              <a:rPr lang="de-DE" dirty="0"/>
-              <a:t> </a:t>
-            </a:r>
-            <a:r>
-              <a:rPr lang="de-DE" dirty="0" err="1"/>
-              <a:t>too</a:t>
-            </a:r>
-            <a:r>
-              <a:rPr lang="de-DE" dirty="0"/>
-              <a:t> time </a:t>
-            </a:r>
-            <a:r>
-              <a:rPr lang="de-DE" dirty="0" err="1"/>
-              <a:t>consuming</a:t>
-            </a:r>
-            <a:r>
-              <a:rPr lang="de-DE" dirty="0"/>
-              <a:t>, </a:t>
-            </a:r>
-            <a:r>
-              <a:rPr lang="de-DE" dirty="0" err="1"/>
-              <a:t>if</a:t>
-            </a:r>
-            <a:r>
-              <a:rPr lang="de-DE" dirty="0"/>
-              <a:t> </a:t>
-            </a:r>
-            <a:r>
-              <a:rPr lang="de-DE" dirty="0" err="1"/>
-              <a:t>f.e</a:t>
-            </a:r>
-            <a:r>
-              <a:rPr lang="de-DE" dirty="0"/>
-              <a:t>. 1e6 </a:t>
-            </a:r>
-            <a:r>
-              <a:rPr lang="de-DE" dirty="0" err="1"/>
-              <a:t>training</a:t>
-            </a:r>
-            <a:r>
-              <a:rPr lang="de-DE" dirty="0"/>
-              <a:t> </a:t>
-            </a:r>
-            <a:r>
-              <a:rPr lang="de-DE" dirty="0" err="1"/>
-              <a:t>data</a:t>
-            </a:r>
-            <a:r>
-              <a:rPr lang="de-DE" dirty="0"/>
-              <a:t> </a:t>
-            </a:r>
-            <a:r>
-              <a:rPr lang="de-DE" dirty="0" err="1"/>
-              <a:t>points</a:t>
-            </a:r>
-            <a:r>
-              <a:rPr lang="de-DE" dirty="0"/>
-              <a:t> </a:t>
-            </a:r>
-            <a:r>
-              <a:rPr lang="de-DE" dirty="0" err="1"/>
-              <a:t>should</a:t>
-            </a:r>
-            <a:r>
-              <a:rPr lang="de-DE" dirty="0"/>
-              <a:t> </a:t>
-            </a:r>
-            <a:r>
-              <a:rPr lang="de-DE" dirty="0" err="1"/>
-              <a:t>be</a:t>
-            </a:r>
-            <a:r>
-              <a:rPr lang="de-DE" dirty="0"/>
-              <a:t> </a:t>
-            </a:r>
-            <a:r>
-              <a:rPr lang="de-DE" dirty="0" err="1"/>
-              <a:t>generated</a:t>
-            </a:r>
-            <a:r>
-              <a:rPr lang="de-DE" dirty="0"/>
-              <a:t> (</a:t>
-            </a:r>
-            <a:r>
-              <a:rPr lang="de-DE" dirty="0" err="1"/>
-              <a:t>would</a:t>
-            </a:r>
-            <a:r>
-              <a:rPr lang="de-DE" dirty="0"/>
-              <a:t> </a:t>
-            </a:r>
-            <a:r>
-              <a:rPr lang="de-DE" dirty="0" err="1"/>
-              <a:t>take</a:t>
-            </a:r>
-            <a:r>
-              <a:rPr lang="de-DE" dirty="0"/>
-              <a:t> </a:t>
-            </a:r>
-            <a:r>
-              <a:rPr lang="de-DE" dirty="0" err="1"/>
-              <a:t>more</a:t>
-            </a:r>
-            <a:r>
-              <a:rPr lang="de-DE" dirty="0"/>
-              <a:t> </a:t>
-            </a:r>
-            <a:r>
-              <a:rPr lang="de-DE" dirty="0" err="1"/>
-              <a:t>than</a:t>
-            </a:r>
-            <a:r>
-              <a:rPr lang="de-DE" dirty="0"/>
-              <a:t> </a:t>
-            </a:r>
-            <a:r>
-              <a:rPr lang="de-DE" dirty="0" err="1"/>
-              <a:t>one</a:t>
-            </a:r>
-            <a:r>
-              <a:rPr lang="de-DE" dirty="0"/>
-              <a:t> </a:t>
-            </a:r>
-            <a:r>
-              <a:rPr lang="de-DE" dirty="0" err="1"/>
-              <a:t>week</a:t>
-            </a:r>
-            <a:r>
-              <a:rPr lang="de-DE" dirty="0"/>
-              <a:t> </a:t>
-            </a:r>
-            <a:r>
-              <a:rPr lang="de-DE" dirty="0" err="1"/>
-              <a:t>computational</a:t>
-            </a:r>
-            <a:r>
-              <a:rPr lang="de-DE" dirty="0"/>
-              <a:t> time on </a:t>
-            </a:r>
-            <a:r>
-              <a:rPr lang="de-DE" dirty="0" err="1"/>
-              <a:t>my</a:t>
-            </a:r>
-            <a:r>
-              <a:rPr lang="de-DE" dirty="0"/>
-              <a:t> </a:t>
-            </a:r>
-            <a:r>
-              <a:rPr lang="de-DE" dirty="0" err="1"/>
-              <a:t>laptop</a:t>
-            </a:r>
-            <a:r>
-              <a:rPr lang="de-DE" dirty="0"/>
-              <a:t>…..)</a:t>
-            </a:r>
-          </a:p>
-          <a:p>
-            <a:pPr marL="457200" indent="-457200">
-              <a:buFont typeface="+mj-lt"/>
-              <a:buAutoNum type="arabicPeriod"/>
-            </a:pPr>
-            <a:r>
-              <a:rPr lang="de-DE" dirty="0"/>
-              <a:t>GEM </a:t>
-            </a:r>
-            <a:r>
-              <a:rPr lang="de-DE" dirty="0" err="1"/>
-              <a:t>with</a:t>
-            </a:r>
-            <a:r>
-              <a:rPr lang="de-DE" dirty="0"/>
-              <a:t> SLSQP (</a:t>
-            </a:r>
-            <a:r>
-              <a:rPr lang="de-DE" dirty="0" err="1"/>
-              <a:t>faster</a:t>
-            </a:r>
-            <a:r>
-              <a:rPr lang="de-DE" dirty="0"/>
-              <a:t> </a:t>
-            </a:r>
-            <a:r>
-              <a:rPr lang="de-DE" dirty="0" err="1"/>
-              <a:t>calculation</a:t>
-            </a:r>
-            <a:r>
-              <a:rPr lang="de-DE" dirty="0"/>
-              <a:t>):</a:t>
-            </a:r>
-          </a:p>
-          <a:p>
-            <a:pPr lvl="1"/>
-            <a:r>
-              <a:rPr lang="de-DE" dirty="0"/>
-              <a:t>Same </a:t>
-            </a:r>
-            <a:r>
-              <a:rPr lang="de-DE" dirty="0" err="1"/>
-              <a:t>problem</a:t>
-            </a:r>
-            <a:r>
-              <a:rPr lang="de-DE" dirty="0"/>
-              <a:t> </a:t>
-            </a:r>
-            <a:r>
-              <a:rPr lang="de-DE" dirty="0" err="1"/>
-              <a:t>as</a:t>
-            </a:r>
-            <a:r>
-              <a:rPr lang="de-DE" dirty="0"/>
-              <a:t> </a:t>
-            </a:r>
-            <a:r>
-              <a:rPr lang="de-DE" dirty="0" err="1"/>
-              <a:t>with</a:t>
-            </a:r>
-            <a:r>
-              <a:rPr lang="de-DE" dirty="0"/>
-              <a:t> </a:t>
-            </a:r>
-            <a:r>
-              <a:rPr lang="de-DE" dirty="0" err="1"/>
-              <a:t>methANNation</a:t>
-            </a:r>
-            <a:r>
-              <a:rPr lang="de-DE" dirty="0"/>
-              <a:t>: </a:t>
-            </a:r>
-            <a:r>
-              <a:rPr lang="de-DE" dirty="0" err="1"/>
-              <a:t>obviously</a:t>
-            </a:r>
-            <a:r>
-              <a:rPr lang="de-DE" dirty="0"/>
-              <a:t> </a:t>
-            </a:r>
-            <a:r>
-              <a:rPr lang="de-DE" dirty="0" err="1"/>
-              <a:t>wrong</a:t>
-            </a:r>
-            <a:r>
-              <a:rPr lang="de-DE" dirty="0"/>
-              <a:t> </a:t>
-            </a:r>
-            <a:r>
-              <a:rPr lang="de-DE" dirty="0" err="1"/>
-              <a:t>solution</a:t>
-            </a:r>
-            <a:r>
-              <a:rPr lang="de-DE" dirty="0"/>
-              <a:t> </a:t>
-            </a:r>
-            <a:r>
-              <a:rPr lang="de-DE" dirty="0" err="1"/>
-              <a:t>found</a:t>
-            </a:r>
-            <a:r>
-              <a:rPr lang="de-DE" dirty="0"/>
-              <a:t> </a:t>
-            </a:r>
-            <a:r>
-              <a:rPr lang="de-DE" dirty="0" err="1"/>
-              <a:t>even</a:t>
-            </a:r>
-            <a:r>
-              <a:rPr lang="de-DE" dirty="0"/>
-              <a:t> </a:t>
-            </a:r>
-            <a:r>
-              <a:rPr lang="de-DE" dirty="0" err="1"/>
-              <a:t>though</a:t>
-            </a:r>
-            <a:r>
-              <a:rPr lang="de-DE" dirty="0"/>
-              <a:t> </a:t>
-            </a:r>
-            <a:r>
-              <a:rPr lang="de-DE" dirty="0" err="1"/>
-              <a:t>solver</a:t>
-            </a:r>
-            <a:r>
-              <a:rPr lang="de-DE" dirty="0"/>
-              <a:t> </a:t>
-            </a:r>
-            <a:r>
-              <a:rPr lang="de-DE" dirty="0" err="1"/>
-              <a:t>converged</a:t>
-            </a:r>
-            <a:r>
-              <a:rPr lang="de-DE" dirty="0"/>
-              <a:t> </a:t>
-            </a:r>
-            <a:r>
-              <a:rPr lang="de-DE" dirty="0">
-                <a:sym typeface="Wingdings" pitchFamily="2" charset="2"/>
-              </a:rPr>
-              <a:t> extra </a:t>
-            </a:r>
-            <a:r>
-              <a:rPr lang="de-DE" dirty="0" err="1">
-                <a:sym typeface="Wingdings" pitchFamily="2" charset="2"/>
-              </a:rPr>
-              <a:t>criterion</a:t>
-            </a:r>
-            <a:r>
-              <a:rPr lang="de-DE" dirty="0">
-                <a:sym typeface="Wingdings" pitchFamily="2" charset="2"/>
-              </a:rPr>
-              <a:t> </a:t>
-            </a:r>
-            <a:r>
-              <a:rPr lang="de-DE" dirty="0" err="1">
-                <a:sym typeface="Wingdings" pitchFamily="2" charset="2"/>
-              </a:rPr>
-              <a:t>needed</a:t>
-            </a:r>
-            <a:r>
-              <a:rPr lang="de-DE" dirty="0">
-                <a:sym typeface="Wingdings" pitchFamily="2" charset="2"/>
-              </a:rPr>
-              <a:t> </a:t>
-            </a:r>
-            <a:r>
-              <a:rPr lang="de-DE" dirty="0" err="1">
-                <a:sym typeface="Wingdings" pitchFamily="2" charset="2"/>
-              </a:rPr>
-              <a:t>to</a:t>
-            </a:r>
-            <a:r>
-              <a:rPr lang="de-DE" dirty="0">
-                <a:sym typeface="Wingdings" pitchFamily="2" charset="2"/>
-              </a:rPr>
-              <a:t> </a:t>
-            </a:r>
-            <a:r>
-              <a:rPr lang="de-DE" dirty="0" err="1">
-                <a:sym typeface="Wingdings" pitchFamily="2" charset="2"/>
-              </a:rPr>
-              <a:t>evaluate</a:t>
-            </a:r>
-            <a:r>
-              <a:rPr lang="de-DE" dirty="0">
-                <a:sym typeface="Wingdings" pitchFamily="2" charset="2"/>
-              </a:rPr>
-              <a:t> </a:t>
-            </a:r>
-            <a:r>
-              <a:rPr lang="de-DE" dirty="0" err="1">
-                <a:sym typeface="Wingdings" pitchFamily="2" charset="2"/>
-              </a:rPr>
-              <a:t>convergence</a:t>
-            </a:r>
-            <a:endParaRPr lang="de-DE" dirty="0">
-              <a:sym typeface="Wingdings" pitchFamily="2" charset="2"/>
-            </a:endParaRPr>
-          </a:p>
-          <a:p>
-            <a:pPr lvl="1"/>
-            <a:r>
-              <a:rPr lang="de-DE" dirty="0">
-                <a:sym typeface="Wingdings" pitchFamily="2" charset="2"/>
-              </a:rPr>
-              <a:t>Problem: additional </a:t>
-            </a:r>
-            <a:r>
-              <a:rPr lang="de-DE" dirty="0" err="1">
-                <a:sym typeface="Wingdings" pitchFamily="2" charset="2"/>
-              </a:rPr>
-              <a:t>two</a:t>
-            </a:r>
-            <a:r>
-              <a:rPr lang="de-DE" dirty="0">
-                <a:sym typeface="Wingdings" pitchFamily="2" charset="2"/>
-              </a:rPr>
-              <a:t> </a:t>
-            </a:r>
-            <a:r>
-              <a:rPr lang="de-DE" dirty="0" err="1">
-                <a:sym typeface="Wingdings" pitchFamily="2" charset="2"/>
-              </a:rPr>
-              <a:t>phase</a:t>
-            </a:r>
-            <a:r>
-              <a:rPr lang="de-DE" dirty="0">
-                <a:sym typeface="Wingdings" pitchFamily="2" charset="2"/>
-              </a:rPr>
-              <a:t> </a:t>
-            </a:r>
-            <a:r>
-              <a:rPr lang="de-DE" dirty="0" err="1">
-                <a:sym typeface="Wingdings" pitchFamily="2" charset="2"/>
-              </a:rPr>
-              <a:t>region</a:t>
-            </a:r>
-            <a:r>
-              <a:rPr lang="de-DE" dirty="0">
-                <a:sym typeface="Wingdings" pitchFamily="2" charset="2"/>
-              </a:rPr>
-              <a:t>  </a:t>
-            </a:r>
-            <a:r>
-              <a:rPr lang="de-DE" dirty="0" err="1">
-                <a:sym typeface="Wingdings" pitchFamily="2" charset="2"/>
-              </a:rPr>
-              <a:t>what</a:t>
-            </a:r>
-            <a:r>
-              <a:rPr lang="de-DE" dirty="0">
-                <a:sym typeface="Wingdings" pitchFamily="2" charset="2"/>
-              </a:rPr>
-              <a:t> </a:t>
-            </a:r>
-            <a:r>
-              <a:rPr lang="de-DE" dirty="0" err="1">
-                <a:sym typeface="Wingdings" pitchFamily="2" charset="2"/>
-              </a:rPr>
-              <a:t>to</a:t>
-            </a:r>
-            <a:r>
-              <a:rPr lang="de-DE" dirty="0">
-                <a:sym typeface="Wingdings" pitchFamily="2" charset="2"/>
-              </a:rPr>
-              <a:t> do…?</a:t>
-            </a:r>
-          </a:p>
-          <a:p>
-            <a:pPr lvl="1"/>
-            <a:r>
-              <a:rPr lang="de-DE" dirty="0" err="1">
-                <a:sym typeface="Wingdings" pitchFamily="2" charset="2"/>
-              </a:rPr>
-              <a:t>For</a:t>
-            </a:r>
-            <a:r>
-              <a:rPr lang="de-DE" dirty="0">
-                <a:sym typeface="Wingdings" pitchFamily="2" charset="2"/>
-              </a:rPr>
-              <a:t> high </a:t>
-            </a:r>
-            <a:r>
-              <a:rPr lang="de-DE" dirty="0" err="1">
-                <a:sym typeface="Wingdings" pitchFamily="2" charset="2"/>
-              </a:rPr>
-              <a:t>temperatures</a:t>
-            </a:r>
-            <a:r>
-              <a:rPr lang="de-DE" dirty="0">
-                <a:sym typeface="Wingdings" pitchFamily="2" charset="2"/>
-              </a:rPr>
-              <a:t> </a:t>
-            </a:r>
-            <a:r>
-              <a:rPr lang="de-DE" dirty="0" err="1">
-                <a:sym typeface="Wingdings" pitchFamily="2" charset="2"/>
-              </a:rPr>
-              <a:t>however</a:t>
-            </a:r>
-            <a:r>
-              <a:rPr lang="de-DE" dirty="0">
-                <a:sym typeface="Wingdings" pitchFamily="2" charset="2"/>
-              </a:rPr>
-              <a:t>, K</a:t>
-            </a:r>
-            <a:r>
-              <a:rPr lang="de-DE" baseline="30000" dirty="0">
-                <a:sym typeface="Wingdings" pitchFamily="2" charset="2"/>
-              </a:rPr>
-              <a:t>0</a:t>
-            </a:r>
-            <a:r>
-              <a:rPr lang="de-DE" dirty="0">
-                <a:sym typeface="Wingdings" pitchFamily="2" charset="2"/>
-              </a:rPr>
-              <a:t> </a:t>
-            </a:r>
-            <a:r>
-              <a:rPr lang="de-DE" dirty="0" err="1">
-                <a:sym typeface="Wingdings" pitchFamily="2" charset="2"/>
-              </a:rPr>
-              <a:t>comparison</a:t>
-            </a:r>
-            <a:r>
-              <a:rPr lang="de-DE" dirty="0">
-                <a:sym typeface="Wingdings" pitchFamily="2" charset="2"/>
-              </a:rPr>
-              <a:t> </a:t>
-            </a:r>
-            <a:r>
-              <a:rPr lang="de-DE" dirty="0" err="1">
-                <a:sym typeface="Wingdings" pitchFamily="2" charset="2"/>
-              </a:rPr>
-              <a:t>would</a:t>
-            </a:r>
-            <a:r>
-              <a:rPr lang="de-DE" dirty="0">
-                <a:sym typeface="Wingdings" pitchFamily="2" charset="2"/>
-              </a:rPr>
-              <a:t> </a:t>
-            </a:r>
-            <a:r>
-              <a:rPr lang="de-DE" dirty="0" err="1">
-                <a:sym typeface="Wingdings" pitchFamily="2" charset="2"/>
-              </a:rPr>
-              <a:t>work</a:t>
-            </a:r>
-            <a:r>
-              <a:rPr lang="de-DE" dirty="0">
-                <a:sym typeface="Wingdings" pitchFamily="2" charset="2"/>
-              </a:rPr>
-              <a:t> </a:t>
-            </a:r>
-            <a:r>
-              <a:rPr lang="de-DE" dirty="0" err="1">
-                <a:sym typeface="Wingdings" pitchFamily="2" charset="2"/>
-              </a:rPr>
-              <a:t>very</a:t>
-            </a:r>
-            <a:r>
-              <a:rPr lang="de-DE" dirty="0">
-                <a:sym typeface="Wingdings" pitchFamily="2" charset="2"/>
-              </a:rPr>
-              <a:t> </a:t>
-            </a:r>
-            <a:r>
-              <a:rPr lang="de-DE" dirty="0" err="1">
-                <a:sym typeface="Wingdings" pitchFamily="2" charset="2"/>
-              </a:rPr>
-              <a:t>good</a:t>
-            </a:r>
-            <a:endParaRPr lang="de-DE" dirty="0">
-              <a:sym typeface="Wingdings" pitchFamily="2" charset="2"/>
-            </a:endParaRPr>
-          </a:p>
-          <a:p>
-            <a:pPr lvl="1"/>
-            <a:r>
-              <a:rPr lang="de-DE" dirty="0" err="1">
-                <a:sym typeface="Wingdings" pitchFamily="2" charset="2"/>
-              </a:rPr>
-              <a:t>Nevertheless</a:t>
-            </a:r>
-            <a:r>
-              <a:rPr lang="de-DE" dirty="0">
-                <a:sym typeface="Wingdings" pitchFamily="2" charset="2"/>
-              </a:rPr>
-              <a:t>: </a:t>
-            </a:r>
-            <a:r>
-              <a:rPr lang="de-DE" dirty="0" err="1">
-                <a:sym typeface="Wingdings" pitchFamily="2" charset="2"/>
-              </a:rPr>
-              <a:t>problematic</a:t>
-            </a:r>
-            <a:r>
-              <a:rPr lang="de-DE" dirty="0">
-                <a:sym typeface="Wingdings" pitchFamily="2" charset="2"/>
-              </a:rPr>
-              <a:t> </a:t>
-            </a:r>
-            <a:r>
-              <a:rPr lang="de-DE" dirty="0" err="1">
-                <a:sym typeface="Wingdings" pitchFamily="2" charset="2"/>
-              </a:rPr>
-              <a:t>as</a:t>
-            </a:r>
-            <a:r>
-              <a:rPr lang="de-DE" dirty="0">
-                <a:sym typeface="Wingdings" pitchFamily="2" charset="2"/>
-              </a:rPr>
-              <a:t> </a:t>
-            </a:r>
-            <a:r>
-              <a:rPr lang="de-DE" dirty="0" err="1">
-                <a:sym typeface="Wingdings" pitchFamily="2" charset="2"/>
-              </a:rPr>
-              <a:t>one</a:t>
-            </a:r>
-            <a:r>
-              <a:rPr lang="de-DE" dirty="0">
-                <a:sym typeface="Wingdings" pitchFamily="2" charset="2"/>
-              </a:rPr>
-              <a:t> </a:t>
-            </a:r>
-            <a:r>
-              <a:rPr lang="de-DE" dirty="0" err="1">
-                <a:sym typeface="Wingdings" pitchFamily="2" charset="2"/>
-              </a:rPr>
-              <a:t>can</a:t>
-            </a:r>
-            <a:r>
-              <a:rPr lang="de-DE" dirty="0">
-                <a:sym typeface="Wingdings" pitchFamily="2" charset="2"/>
-              </a:rPr>
-              <a:t> </a:t>
-            </a:r>
-            <a:r>
-              <a:rPr lang="de-DE" dirty="0" err="1">
-                <a:sym typeface="Wingdings" pitchFamily="2" charset="2"/>
-              </a:rPr>
-              <a:t>never</a:t>
-            </a:r>
-            <a:r>
-              <a:rPr lang="de-DE" dirty="0">
-                <a:sym typeface="Wingdings" pitchFamily="2" charset="2"/>
-              </a:rPr>
-              <a:t> </a:t>
-            </a:r>
-            <a:r>
-              <a:rPr lang="de-DE" dirty="0" err="1">
-                <a:sym typeface="Wingdings" pitchFamily="2" charset="2"/>
-              </a:rPr>
-              <a:t>be</a:t>
-            </a:r>
-            <a:r>
-              <a:rPr lang="de-DE" dirty="0">
-                <a:sym typeface="Wingdings" pitchFamily="2" charset="2"/>
-              </a:rPr>
-              <a:t> 100% </a:t>
-            </a:r>
-            <a:r>
-              <a:rPr lang="de-DE" dirty="0" err="1">
-                <a:sym typeface="Wingdings" pitchFamily="2" charset="2"/>
-              </a:rPr>
-              <a:t>sure</a:t>
-            </a:r>
-            <a:r>
-              <a:rPr lang="de-DE" dirty="0">
-                <a:sym typeface="Wingdings" pitchFamily="2" charset="2"/>
-              </a:rPr>
-              <a:t> </a:t>
-            </a:r>
-            <a:r>
-              <a:rPr lang="de-DE" dirty="0" err="1">
-                <a:sym typeface="Wingdings" pitchFamily="2" charset="2"/>
-              </a:rPr>
-              <a:t>whether</a:t>
-            </a:r>
-            <a:r>
-              <a:rPr lang="de-DE" dirty="0">
-                <a:sym typeface="Wingdings" pitchFamily="2" charset="2"/>
-              </a:rPr>
-              <a:t> </a:t>
-            </a:r>
-            <a:r>
-              <a:rPr lang="de-DE" dirty="0" err="1">
-                <a:sym typeface="Wingdings" pitchFamily="2" charset="2"/>
-              </a:rPr>
-              <a:t>solution</a:t>
-            </a:r>
-            <a:r>
-              <a:rPr lang="de-DE" dirty="0">
-                <a:sym typeface="Wingdings" pitchFamily="2" charset="2"/>
-              </a:rPr>
-              <a:t> </a:t>
-            </a:r>
-            <a:r>
-              <a:rPr lang="de-DE" dirty="0" err="1">
-                <a:sym typeface="Wingdings" pitchFamily="2" charset="2"/>
-              </a:rPr>
-              <a:t>is</a:t>
-            </a:r>
-            <a:r>
-              <a:rPr lang="de-DE" dirty="0">
-                <a:sym typeface="Wingdings" pitchFamily="2" charset="2"/>
-              </a:rPr>
-              <a:t> </a:t>
-            </a:r>
-            <a:r>
-              <a:rPr lang="de-DE" dirty="0" err="1">
-                <a:sym typeface="Wingdings" pitchFamily="2" charset="2"/>
-              </a:rPr>
-              <a:t>correct</a:t>
-            </a:r>
-            <a:r>
-              <a:rPr lang="de-DE" dirty="0">
-                <a:sym typeface="Wingdings" pitchFamily="2" charset="2"/>
-              </a:rPr>
-              <a:t> </a:t>
-            </a:r>
-            <a:r>
-              <a:rPr lang="de-DE" dirty="0" err="1">
-                <a:sym typeface="Wingdings" pitchFamily="2" charset="2"/>
-              </a:rPr>
-              <a:t>or</a:t>
-            </a:r>
-            <a:r>
-              <a:rPr lang="de-DE" dirty="0">
-                <a:sym typeface="Wingdings" pitchFamily="2" charset="2"/>
-              </a:rPr>
-              <a:t> not</a:t>
-            </a:r>
-          </a:p>
-          <a:p>
-            <a:pPr marL="457200" indent="-457200">
-              <a:buFont typeface="+mj-lt"/>
-              <a:buAutoNum type="arabicPeriod"/>
-            </a:pPr>
-            <a:r>
-              <a:rPr lang="de-DE" dirty="0" err="1">
-                <a:sym typeface="Wingdings" pitchFamily="2" charset="2"/>
-              </a:rPr>
-              <a:t>Another</a:t>
-            </a:r>
-            <a:r>
-              <a:rPr lang="de-DE" dirty="0">
-                <a:sym typeface="Wingdings" pitchFamily="2" charset="2"/>
-              </a:rPr>
-              <a:t> </a:t>
-            </a:r>
-            <a:r>
-              <a:rPr lang="de-DE" dirty="0" err="1">
-                <a:sym typeface="Wingdings" pitchFamily="2" charset="2"/>
-              </a:rPr>
-              <a:t>problem</a:t>
-            </a:r>
-            <a:r>
-              <a:rPr lang="de-DE" dirty="0">
-                <a:sym typeface="Wingdings" pitchFamily="2" charset="2"/>
-              </a:rPr>
-              <a:t>:</a:t>
-            </a:r>
-          </a:p>
-          <a:p>
-            <a:pPr lvl="1"/>
-            <a:r>
-              <a:rPr lang="de-DE" dirty="0">
-                <a:sym typeface="Wingdings" pitchFamily="2" charset="2"/>
-              </a:rPr>
-              <a:t>A </a:t>
-            </a:r>
-            <a:r>
-              <a:rPr lang="de-DE" dirty="0" err="1">
-                <a:sym typeface="Wingdings" pitchFamily="2" charset="2"/>
-              </a:rPr>
-              <a:t>criterion</a:t>
-            </a:r>
-            <a:r>
-              <a:rPr lang="de-DE" dirty="0">
-                <a:sym typeface="Wingdings" pitchFamily="2" charset="2"/>
-              </a:rPr>
-              <a:t> </a:t>
-            </a:r>
-            <a:r>
-              <a:rPr lang="de-DE" dirty="0" err="1">
-                <a:sym typeface="Wingdings" pitchFamily="2" charset="2"/>
-              </a:rPr>
-              <a:t>to</a:t>
-            </a:r>
-            <a:r>
-              <a:rPr lang="de-DE" dirty="0">
-                <a:sym typeface="Wingdings" pitchFamily="2" charset="2"/>
-              </a:rPr>
-              <a:t> </a:t>
-            </a:r>
-            <a:r>
-              <a:rPr lang="de-DE" dirty="0" err="1">
-                <a:sym typeface="Wingdings" pitchFamily="2" charset="2"/>
-              </a:rPr>
-              <a:t>determine</a:t>
-            </a:r>
-            <a:r>
-              <a:rPr lang="de-DE" dirty="0">
-                <a:sym typeface="Wingdings" pitchFamily="2" charset="2"/>
-              </a:rPr>
-              <a:t> </a:t>
-            </a:r>
-            <a:r>
-              <a:rPr lang="de-DE" dirty="0" err="1">
-                <a:sym typeface="Wingdings" pitchFamily="2" charset="2"/>
-              </a:rPr>
-              <a:t>confidently</a:t>
-            </a:r>
-            <a:r>
-              <a:rPr lang="de-DE" dirty="0">
-                <a:sym typeface="Wingdings" pitchFamily="2" charset="2"/>
-              </a:rPr>
-              <a:t> </a:t>
-            </a:r>
-            <a:r>
-              <a:rPr lang="de-DE" dirty="0" err="1">
-                <a:sym typeface="Wingdings" pitchFamily="2" charset="2"/>
-              </a:rPr>
-              <a:t>whether</a:t>
-            </a:r>
-            <a:r>
-              <a:rPr lang="de-DE" dirty="0">
-                <a:sym typeface="Wingdings" pitchFamily="2" charset="2"/>
-              </a:rPr>
-              <a:t> </a:t>
-            </a:r>
-            <a:r>
-              <a:rPr lang="de-DE" dirty="0" err="1">
-                <a:sym typeface="Wingdings" pitchFamily="2" charset="2"/>
-              </a:rPr>
-              <a:t>the</a:t>
-            </a:r>
-            <a:r>
-              <a:rPr lang="de-DE" dirty="0">
-                <a:sym typeface="Wingdings" pitchFamily="2" charset="2"/>
-              </a:rPr>
-              <a:t> </a:t>
-            </a:r>
-            <a:r>
-              <a:rPr lang="de-DE" dirty="0" err="1">
-                <a:sym typeface="Wingdings" pitchFamily="2" charset="2"/>
-              </a:rPr>
-              <a:t>single</a:t>
-            </a:r>
-            <a:r>
-              <a:rPr lang="de-DE" dirty="0">
-                <a:sym typeface="Wingdings" pitchFamily="2" charset="2"/>
-              </a:rPr>
-              <a:t> </a:t>
-            </a:r>
-            <a:r>
-              <a:rPr lang="de-DE" dirty="0" err="1">
-                <a:sym typeface="Wingdings" pitchFamily="2" charset="2"/>
-              </a:rPr>
-              <a:t>phase</a:t>
-            </a:r>
-            <a:r>
-              <a:rPr lang="de-DE" dirty="0">
-                <a:sym typeface="Wingdings" pitchFamily="2" charset="2"/>
-              </a:rPr>
-              <a:t> </a:t>
-            </a:r>
-            <a:r>
-              <a:rPr lang="de-DE" dirty="0" err="1">
-                <a:sym typeface="Wingdings" pitchFamily="2" charset="2"/>
-              </a:rPr>
-              <a:t>solution</a:t>
-            </a:r>
-            <a:r>
-              <a:rPr lang="de-DE" dirty="0">
-                <a:sym typeface="Wingdings" pitchFamily="2" charset="2"/>
-              </a:rPr>
-              <a:t> </a:t>
-            </a:r>
-            <a:r>
-              <a:rPr lang="de-DE" dirty="0" err="1">
-                <a:sym typeface="Wingdings" pitchFamily="2" charset="2"/>
-              </a:rPr>
-              <a:t>is</a:t>
-            </a:r>
-            <a:r>
-              <a:rPr lang="de-DE" dirty="0">
-                <a:sym typeface="Wingdings" pitchFamily="2" charset="2"/>
-              </a:rPr>
-              <a:t> </a:t>
-            </a:r>
-            <a:r>
-              <a:rPr lang="de-DE" dirty="0" err="1">
-                <a:sym typeface="Wingdings" pitchFamily="2" charset="2"/>
-              </a:rPr>
-              <a:t>vapor</a:t>
-            </a:r>
-            <a:r>
-              <a:rPr lang="de-DE" dirty="0">
-                <a:sym typeface="Wingdings" pitchFamily="2" charset="2"/>
-              </a:rPr>
-              <a:t> </a:t>
-            </a:r>
-            <a:r>
-              <a:rPr lang="de-DE" dirty="0" err="1">
-                <a:sym typeface="Wingdings" pitchFamily="2" charset="2"/>
-              </a:rPr>
-              <a:t>or</a:t>
-            </a:r>
-            <a:r>
-              <a:rPr lang="de-DE" dirty="0">
-                <a:sym typeface="Wingdings" pitchFamily="2" charset="2"/>
-              </a:rPr>
-              <a:t> liquid </a:t>
-            </a:r>
-            <a:r>
-              <a:rPr lang="de-DE" dirty="0" err="1">
-                <a:sym typeface="Wingdings" pitchFamily="2" charset="2"/>
-              </a:rPr>
-              <a:t>is</a:t>
-            </a:r>
-            <a:r>
-              <a:rPr lang="de-DE" dirty="0">
-                <a:sym typeface="Wingdings" pitchFamily="2" charset="2"/>
-              </a:rPr>
-              <a:t> still </a:t>
-            </a:r>
-            <a:r>
-              <a:rPr lang="de-DE" dirty="0" err="1">
-                <a:sym typeface="Wingdings" pitchFamily="2" charset="2"/>
-              </a:rPr>
-              <a:t>needed</a:t>
-            </a:r>
-            <a:r>
-              <a:rPr lang="de-DE" dirty="0">
-                <a:sym typeface="Wingdings" pitchFamily="2" charset="2"/>
-              </a:rPr>
-              <a:t>, </a:t>
-            </a:r>
-            <a:r>
-              <a:rPr lang="de-DE" dirty="0" err="1">
-                <a:sym typeface="Wingdings" pitchFamily="2" charset="2"/>
-              </a:rPr>
-              <a:t>for</a:t>
-            </a:r>
-            <a:r>
-              <a:rPr lang="de-DE" dirty="0">
-                <a:sym typeface="Wingdings" pitchFamily="2" charset="2"/>
-              </a:rPr>
-              <a:t> VLE </a:t>
-            </a:r>
-            <a:r>
-              <a:rPr lang="de-DE" dirty="0" err="1">
-                <a:sym typeface="Wingdings" pitchFamily="2" charset="2"/>
-              </a:rPr>
-              <a:t>it‘s</a:t>
-            </a:r>
-            <a:r>
-              <a:rPr lang="de-DE" dirty="0">
-                <a:sym typeface="Wingdings" pitchFamily="2" charset="2"/>
-              </a:rPr>
-              <a:t> not a </a:t>
-            </a:r>
-            <a:r>
-              <a:rPr lang="de-DE" dirty="0" err="1">
-                <a:sym typeface="Wingdings" pitchFamily="2" charset="2"/>
-              </a:rPr>
-              <a:t>problem</a:t>
-            </a:r>
-            <a:r>
-              <a:rPr lang="de-DE" dirty="0">
-                <a:sym typeface="Wingdings" pitchFamily="2" charset="2"/>
-              </a:rPr>
-              <a:t> </a:t>
-            </a:r>
-            <a:r>
-              <a:rPr lang="de-DE" dirty="0" err="1">
-                <a:sym typeface="Wingdings" pitchFamily="2" charset="2"/>
-              </a:rPr>
-              <a:t>as</a:t>
-            </a:r>
-            <a:r>
-              <a:rPr lang="de-DE" dirty="0">
-                <a:sym typeface="Wingdings" pitchFamily="2" charset="2"/>
-              </a:rPr>
-              <a:t> </a:t>
-            </a:r>
-            <a:r>
-              <a:rPr lang="de-DE" dirty="0" err="1">
-                <a:sym typeface="Wingdings" pitchFamily="2" charset="2"/>
-              </a:rPr>
-              <a:t>compressibility</a:t>
-            </a:r>
-            <a:r>
-              <a:rPr lang="de-DE" dirty="0">
-                <a:sym typeface="Wingdings" pitchFamily="2" charset="2"/>
-              </a:rPr>
-              <a:t> </a:t>
-            </a:r>
-            <a:r>
-              <a:rPr lang="de-DE" dirty="0" err="1">
-                <a:sym typeface="Wingdings" pitchFamily="2" charset="2"/>
-              </a:rPr>
-              <a:t>factors</a:t>
-            </a:r>
-            <a:r>
-              <a:rPr lang="de-DE" dirty="0">
-                <a:sym typeface="Wingdings" pitchFamily="2" charset="2"/>
-              </a:rPr>
-              <a:t> Z</a:t>
-            </a:r>
-            <a:r>
-              <a:rPr lang="de-DE" baseline="-25000" dirty="0">
-                <a:sym typeface="Wingdings" pitchFamily="2" charset="2"/>
-              </a:rPr>
-              <a:t>L</a:t>
-            </a:r>
-            <a:r>
-              <a:rPr lang="de-DE" dirty="0">
-                <a:sym typeface="Wingdings" pitchFamily="2" charset="2"/>
-              </a:rPr>
-              <a:t> and </a:t>
-            </a:r>
-            <a:r>
-              <a:rPr lang="de-DE" dirty="0" err="1">
-                <a:sym typeface="Wingdings" pitchFamily="2" charset="2"/>
-              </a:rPr>
-              <a:t>Z</a:t>
-            </a:r>
-            <a:r>
-              <a:rPr lang="de-DE" baseline="-25000" dirty="0" err="1">
-                <a:sym typeface="Wingdings" pitchFamily="2" charset="2"/>
-              </a:rPr>
-              <a:t>v</a:t>
-            </a:r>
-            <a:r>
-              <a:rPr lang="de-DE" dirty="0">
-                <a:sym typeface="Wingdings" pitchFamily="2" charset="2"/>
-              </a:rPr>
-              <a:t> </a:t>
-            </a:r>
-            <a:r>
-              <a:rPr lang="de-DE" dirty="0" err="1">
-                <a:sym typeface="Wingdings" pitchFamily="2" charset="2"/>
-              </a:rPr>
-              <a:t>can</a:t>
-            </a:r>
-            <a:r>
-              <a:rPr lang="de-DE" dirty="0">
-                <a:sym typeface="Wingdings" pitchFamily="2" charset="2"/>
-              </a:rPr>
-              <a:t> </a:t>
-            </a:r>
-            <a:r>
-              <a:rPr lang="de-DE" dirty="0" err="1">
-                <a:sym typeface="Wingdings" pitchFamily="2" charset="2"/>
-              </a:rPr>
-              <a:t>easily</a:t>
-            </a:r>
-            <a:r>
-              <a:rPr lang="de-DE" dirty="0">
-                <a:sym typeface="Wingdings" pitchFamily="2" charset="2"/>
-              </a:rPr>
-              <a:t> </a:t>
-            </a:r>
-            <a:r>
-              <a:rPr lang="de-DE" dirty="0" err="1">
-                <a:sym typeface="Wingdings" pitchFamily="2" charset="2"/>
-              </a:rPr>
-              <a:t>be</a:t>
-            </a:r>
-            <a:r>
-              <a:rPr lang="de-DE" dirty="0">
-                <a:sym typeface="Wingdings" pitchFamily="2" charset="2"/>
-              </a:rPr>
-              <a:t> </a:t>
-            </a:r>
-            <a:r>
-              <a:rPr lang="de-DE">
-                <a:sym typeface="Wingdings" pitchFamily="2" charset="2"/>
-              </a:rPr>
-              <a:t>compared</a:t>
-            </a:r>
-            <a:endParaRPr lang="de-DE" dirty="0">
-              <a:sym typeface="Wingdings" pitchFamily="2" charset="2"/>
-            </a:endParaRPr>
-          </a:p>
-          <a:p>
-            <a:pPr lvl="1"/>
-            <a:endParaRPr lang="de-DE" dirty="0"/>
-          </a:p>
-        </p:txBody>
-      </p:sp>
+        </p:nvPicPr>
+        <p:blipFill>
+          <a:blip r:embed="rId2">
+            <a:extLst>
+              <a:ext uri="{28A0092B-C50C-407E-A947-70E740481C1C}">
+                <a14:useLocalDpi xmlns:a14="http://schemas.microsoft.com/office/drawing/2010/main" val="0"/>
+              </a:ext>
+            </a:extLst>
+          </a:blip>
+          <a:srcRect l="50524"/>
+          <a:stretch/>
+        </p:blipFill>
+        <p:spPr>
+          <a:xfrm>
+            <a:off x="6456040" y="1250156"/>
+            <a:ext cx="4536604" cy="5003800"/>
+          </a:xfrm>
+        </p:spPr>
+      </p:pic>
+      <p:pic>
+        <p:nvPicPr>
+          <p:cNvPr id="6" name="Grafik 5">
+            <a:extLst>
+              <a:ext uri="{FF2B5EF4-FFF2-40B4-BE49-F238E27FC236}">
+                <a16:creationId xmlns:a16="http://schemas.microsoft.com/office/drawing/2014/main" id="{B0C87A34-ACCE-16B3-0DDB-EBFC50C90ED1}"/>
+              </a:ext>
+            </a:extLst>
+          </p:cNvPr>
+          <p:cNvPicPr>
+            <a:picLocks noChangeAspect="1"/>
+          </p:cNvPicPr>
+          <p:nvPr/>
+        </p:nvPicPr>
+        <p:blipFill>
+          <a:blip r:embed="rId3"/>
+          <a:stretch>
+            <a:fillRect/>
+          </a:stretch>
+        </p:blipFill>
+        <p:spPr>
+          <a:xfrm>
+            <a:off x="842715" y="1844824"/>
+            <a:ext cx="5549900" cy="3606800"/>
+          </a:xfrm>
+          <a:prstGeom prst="rect">
+            <a:avLst/>
+          </a:prstGeom>
+        </p:spPr>
+      </p:pic>
     </p:spTree>
     <p:extLst>
       <p:ext uri="{BB962C8B-B14F-4D97-AF65-F5344CB8AC3E}">
-        <p14:creationId xmlns:p14="http://schemas.microsoft.com/office/powerpoint/2010/main" val="2324697207"/>
+        <p14:creationId xmlns:p14="http://schemas.microsoft.com/office/powerpoint/2010/main" val="1035434722"/>
       </p:ext>
     </p:extLst>
   </p:cSld>
@@ -6611,7 +7071,13 @@
       </p:grpSpPr>
       <p:sp>
         <p:nvSpPr>
-          <p:cNvPr id="4" name="Titel 3"/>
+          <p:cNvPr id="2" name="Titel 1">
+            <a:extLst>
+              <a:ext uri="{FF2B5EF4-FFF2-40B4-BE49-F238E27FC236}">
+                <a16:creationId xmlns:a16="http://schemas.microsoft.com/office/drawing/2014/main" id="{3AA45EE9-A3DC-0F94-C0D8-20BE3F8945DA}"/>
+              </a:ext>
+            </a:extLst>
+          </p:cNvPr>
           <p:cNvSpPr>
             <a:spLocks noGrp="1"/>
           </p:cNvSpPr>
@@ -6625,16 +7091,104 @@
           <a:lstStyle/>
           <a:p>
             <a:r>
-              <a:rPr lang="en-US" dirty="0"/>
-              <a:t>Section Title</a:t>
+              <a:rPr lang="de-DE" dirty="0"/>
+              <a:t>Further </a:t>
+            </a:r>
+            <a:r>
+              <a:rPr lang="de-DE" dirty="0" err="1"/>
+              <a:t>literature</a:t>
+            </a:r>
+            <a:r>
+              <a:rPr lang="de-DE" dirty="0"/>
+              <a:t> </a:t>
+            </a:r>
+            <a:r>
+              <a:rPr lang="de-DE" dirty="0" err="1"/>
+              <a:t>comparisons</a:t>
+            </a:r>
+            <a:r>
+              <a:rPr lang="de-DE" dirty="0"/>
+              <a:t> – Van </a:t>
+            </a:r>
+            <a:r>
+              <a:rPr lang="de-DE" dirty="0" err="1"/>
+              <a:t>Bennekom</a:t>
+            </a:r>
+            <a:r>
+              <a:rPr lang="de-DE" dirty="0"/>
+              <a:t> 2012 Figure 9</a:t>
             </a:r>
           </a:p>
         </p:txBody>
       </p:sp>
+      <p:pic>
+        <p:nvPicPr>
+          <p:cNvPr id="4" name="Inhaltsplatzhalter 4" descr="Ein Bild, das Diagramm, Reihe, Screenshot enthält.&#10;&#10;KI-generierte Inhalte können fehlerhaft sein.">
+            <a:extLst>
+              <a:ext uri="{FF2B5EF4-FFF2-40B4-BE49-F238E27FC236}">
+                <a16:creationId xmlns:a16="http://schemas.microsoft.com/office/drawing/2014/main" id="{D9CD8D66-4CDD-AC54-9C66-3DF014B17BA1}"/>
+              </a:ext>
+            </a:extLst>
+          </p:cNvPr>
+          <p:cNvPicPr>
+            <a:picLocks noGrp="1" noChangeAspect="1"/>
+          </p:cNvPicPr>
+          <p:nvPr>
+            <p:ph idx="1"/>
+          </p:nvPr>
+        </p:nvPicPr>
+        <p:blipFill>
+          <a:blip r:embed="rId2">
+            <a:extLst>
+              <a:ext uri="{28A0092B-C50C-407E-A947-70E740481C1C}">
+                <a14:useLocalDpi xmlns:a14="http://schemas.microsoft.com/office/drawing/2010/main" val="0"/>
+              </a:ext>
+            </a:extLst>
+          </a:blip>
+          <a:srcRect r="50261"/>
+          <a:stretch/>
+        </p:blipFill>
+        <p:spPr>
+          <a:xfrm>
+            <a:off x="1055440" y="1250156"/>
+            <a:ext cx="4560788" cy="5003800"/>
+          </a:xfrm>
+        </p:spPr>
+      </p:pic>
+      <p:pic>
+        <p:nvPicPr>
+          <p:cNvPr id="5" name="Grafik 4">
+            <a:extLst>
+              <a:ext uri="{FF2B5EF4-FFF2-40B4-BE49-F238E27FC236}">
+                <a16:creationId xmlns:a16="http://schemas.microsoft.com/office/drawing/2014/main" id="{F0AF1432-E4ED-5103-A110-D135A9426738}"/>
+              </a:ext>
+            </a:extLst>
+          </p:cNvPr>
+          <p:cNvPicPr>
+            <a:picLocks noChangeAspect="1"/>
+          </p:cNvPicPr>
+          <p:nvPr/>
+        </p:nvPicPr>
+        <p:blipFill>
+          <a:blip r:embed="rId3"/>
+          <a:stretch>
+            <a:fillRect/>
+          </a:stretch>
+        </p:blipFill>
+        <p:spPr>
+          <a:xfrm>
+            <a:off x="6096000" y="1878806"/>
+            <a:ext cx="5219700" cy="3746500"/>
+          </a:xfrm>
+          <a:prstGeom prst="rect">
+            <a:avLst/>
+          </a:prstGeom>
+        </p:spPr>
+      </p:pic>
     </p:spTree>
     <p:extLst>
       <p:ext uri="{BB962C8B-B14F-4D97-AF65-F5344CB8AC3E}">
-        <p14:creationId xmlns:p14="http://schemas.microsoft.com/office/powerpoint/2010/main" val="3110794164"/>
+        <p14:creationId xmlns:p14="http://schemas.microsoft.com/office/powerpoint/2010/main" val="3312014769"/>
       </p:ext>
     </p:extLst>
   </p:cSld>
@@ -6663,12 +7217,18 @@
       </p:grpSpPr>
       <p:sp>
         <p:nvSpPr>
-          <p:cNvPr id="4" name="Titel 3"/>
+          <p:cNvPr id="2" name="Titel 1">
+            <a:extLst>
+              <a:ext uri="{FF2B5EF4-FFF2-40B4-BE49-F238E27FC236}">
+                <a16:creationId xmlns:a16="http://schemas.microsoft.com/office/drawing/2014/main" id="{915C58A4-4E54-1127-B521-7CD9C17769A9}"/>
+              </a:ext>
+            </a:extLst>
+          </p:cNvPr>
           <p:cNvSpPr>
             <a:spLocks noGrp="1"/>
           </p:cNvSpPr>
           <p:nvPr>
-            <p:ph type="ctrTitle"/>
+            <p:ph type="title"/>
           </p:nvPr>
         </p:nvSpPr>
         <p:spPr/>
@@ -6677,60 +7237,101 @@
           <a:lstStyle/>
           <a:p>
             <a:r>
-              <a:rPr lang="en-US" dirty="0"/>
-              <a:t>Acknowledgement</a:t>
-            </a:r>
+              <a:rPr lang="de-DE" dirty="0"/>
+              <a:t>Further </a:t>
+            </a:r>
+            <a:r>
+              <a:rPr lang="de-DE" dirty="0" err="1"/>
+              <a:t>literature</a:t>
+            </a:r>
+            <a:r>
+              <a:rPr lang="de-DE" dirty="0"/>
+              <a:t> </a:t>
+            </a:r>
+            <a:r>
+              <a:rPr lang="de-DE" dirty="0" err="1"/>
+              <a:t>comparisons</a:t>
+            </a:r>
+            <a:r>
+              <a:rPr lang="de-DE" dirty="0"/>
+              <a:t> - </a:t>
+            </a:r>
+            <a:r>
+              <a:rPr lang="de-DE" sz="2400" dirty="0"/>
+              <a:t>Stangeland 2018 Figure 1 (a)</a:t>
+            </a:r>
+            <a:endParaRPr lang="de-DE" dirty="0"/>
           </a:p>
         </p:txBody>
       </p:sp>
-      <p:sp>
-        <p:nvSpPr>
-          <p:cNvPr id="5" name="Untertitel 4"/>
-          <p:cNvSpPr>
-            <a:spLocks noGrp="1"/>
-          </p:cNvSpPr>
+      <p:pic>
+        <p:nvPicPr>
+          <p:cNvPr id="5" name="Inhaltsplatzhalter 4" descr="Ein Bild, das Diagramm, Reihe enthält.&#10;&#10;KI-generierte Inhalte können fehlerhaft sein.">
+            <a:extLst>
+              <a:ext uri="{FF2B5EF4-FFF2-40B4-BE49-F238E27FC236}">
+                <a16:creationId xmlns:a16="http://schemas.microsoft.com/office/drawing/2014/main" id="{EC810934-4966-EB8F-771F-9C43F36D05B8}"/>
+              </a:ext>
+            </a:extLst>
+          </p:cNvPr>
+          <p:cNvPicPr>
+            <a:picLocks noGrp="1" noChangeAspect="1"/>
+          </p:cNvPicPr>
           <p:nvPr>
-            <p:ph type="subTitle" idx="1"/>
+            <p:ph idx="1"/>
           </p:nvPr>
-        </p:nvSpPr>
-        <p:spPr/>
-        <p:txBody>
-          <a:bodyPr>
-            <a:normAutofit/>
-          </a:bodyPr>
-          <a:lstStyle/>
-          <a:p>
-            <a:pPr algn="l">
-              <a:tabLst>
-                <a:tab pos="1255713" algn="l"/>
-              </a:tabLst>
-            </a:pPr>
-            <a:r>
-              <a:rPr lang="en-US" dirty="0"/>
-              <a:t>People:	Names</a:t>
-            </a:r>
-          </a:p>
-          <a:p>
-            <a:pPr algn="l"/>
-            <a:endParaRPr lang="en-US" dirty="0"/>
-          </a:p>
-          <a:p>
-            <a:pPr algn="l">
-              <a:tabLst>
-                <a:tab pos="1255713" algn="l"/>
-              </a:tabLst>
-            </a:pPr>
-            <a:r>
-              <a:rPr lang="en-US" dirty="0"/>
-              <a:t>Funding:	Sources</a:t>
-            </a:r>
-          </a:p>
-        </p:txBody>
-      </p:sp>
+        </p:nvPicPr>
+        <p:blipFill>
+          <a:blip r:embed="rId2">
+            <a:extLst>
+              <a:ext uri="{28A0092B-C50C-407E-A947-70E740481C1C}">
+                <a14:useLocalDpi xmlns:a14="http://schemas.microsoft.com/office/drawing/2010/main" val="0"/>
+              </a:ext>
+            </a:extLst>
+          </a:blip>
+          <a:srcRect r="50259"/>
+          <a:stretch/>
+        </p:blipFill>
+        <p:spPr>
+          <a:xfrm>
+            <a:off x="623392" y="1340768"/>
+            <a:ext cx="4598888" cy="4838700"/>
+          </a:xfrm>
+        </p:spPr>
+      </p:pic>
+      <p:pic>
+        <p:nvPicPr>
+          <p:cNvPr id="6" name="Grafik 5">
+            <a:extLst>
+              <a:ext uri="{FF2B5EF4-FFF2-40B4-BE49-F238E27FC236}">
+                <a16:creationId xmlns:a16="http://schemas.microsoft.com/office/drawing/2014/main" id="{081A5013-CEB6-2DCE-0939-D902D482D2D9}"/>
+              </a:ext>
+            </a:extLst>
+          </p:cNvPr>
+          <p:cNvPicPr>
+            <a:picLocks noChangeAspect="1"/>
+          </p:cNvPicPr>
+          <p:nvPr/>
+        </p:nvPicPr>
+        <p:blipFill>
+          <a:blip r:embed="rId3"/>
+          <a:stretch>
+            <a:fillRect/>
+          </a:stretch>
+        </p:blipFill>
+        <p:spPr>
+          <a:xfrm>
+            <a:off x="6096000" y="1747168"/>
+            <a:ext cx="5029200" cy="4025900"/>
+          </a:xfrm>
+          <a:prstGeom prst="rect">
+            <a:avLst/>
+          </a:prstGeom>
+        </p:spPr>
+      </p:pic>
     </p:spTree>
     <p:extLst>
       <p:ext uri="{BB962C8B-B14F-4D97-AF65-F5344CB8AC3E}">
-        <p14:creationId xmlns:p14="http://schemas.microsoft.com/office/powerpoint/2010/main" val="4173971235"/>
+        <p14:creationId xmlns:p14="http://schemas.microsoft.com/office/powerpoint/2010/main" val="1792763303"/>
       </p:ext>
     </p:extLst>
   </p:cSld>

</xml_diff>